<commit_message>
placeholders de equipamentos, promoção e recálculo dinâmico de parcela por edição de quantidade
</commit_message>
<xml_diff>
--- a/simulador_duofitness/templates/uno.pptx
+++ b/simulador_duofitness/templates/uno.pptx
@@ -20,31 +20,28 @@
     <p:sldId id="268" r:id="rId14"/>
     <p:sldId id="269" r:id="rId15"/>
     <p:sldId id="270" r:id="rId16"/>
-    <p:sldId id="271" r:id="rId17"/>
-    <p:sldId id="272" r:id="rId18"/>
-    <p:sldId id="273" r:id="rId19"/>
-    <p:sldId id="274" r:id="rId20"/>
-    <p:sldId id="275" r:id="rId21"/>
-    <p:sldId id="276" r:id="rId22"/>
-    <p:sldId id="277" r:id="rId23"/>
-    <p:sldId id="278" r:id="rId24"/>
-    <p:sldId id="279" r:id="rId25"/>
-    <p:sldId id="280" r:id="rId26"/>
-    <p:sldId id="281" r:id="rId27"/>
-    <p:sldId id="282" r:id="rId28"/>
+    <p:sldId id="274" r:id="rId17"/>
+    <p:sldId id="271" r:id="rId18"/>
+    <p:sldId id="275" r:id="rId19"/>
+    <p:sldId id="277" r:id="rId20"/>
+    <p:sldId id="283" r:id="rId21"/>
+    <p:sldId id="279" r:id="rId22"/>
+    <p:sldId id="280" r:id="rId23"/>
+    <p:sldId id="281" r:id="rId24"/>
+    <p:sldId id="282" r:id="rId25"/>
   </p:sldIdLst>
   <p:sldSz cx="18288000" cy="10287000"/>
   <p:notesSz cx="6858000" cy="9144000"/>
   <p:embeddedFontLst>
     <p:embeddedFont>
       <p:font typeface="Open Sans" pitchFamily="2" charset="0"/>
-      <p:regular r:id="rId29"/>
-      <p:bold r:id="rId30"/>
-      <p:boldItalic r:id="rId31"/>
+      <p:regular r:id="rId26"/>
+      <p:bold r:id="rId27"/>
+      <p:boldItalic r:id="rId28"/>
     </p:embeddedFont>
     <p:embeddedFont>
       <p:font typeface="Open Sans Bold" pitchFamily="2" charset="0"/>
-      <p:bold r:id="rId32"/>
+      <p:bold r:id="rId29"/>
     </p:embeddedFont>
   </p:embeddedFontLst>
   <p:defaultTextStyle>
@@ -3734,7 +3731,7 @@
         <p:spPr>
           <a:xfrm>
             <a:off x="9144000" y="7636273"/>
-            <a:ext cx="6705600" cy="1045223"/>
+            <a:ext cx="9525000" cy="1045223"/>
           </a:xfrm>
           <a:prstGeom prst="rect">
             <a:avLst/>
@@ -3746,7 +3743,7 @@
           </a:bodyPr>
           <a:lstStyle/>
           <a:p>
-            <a:pPr algn="ctr">
+            <a:pPr>
               <a:lnSpc>
                 <a:spcPts val="8659"/>
               </a:lnSpc>
@@ -3773,7 +3770,7 @@
                 <a:cs typeface="Open Sans Bold"/>
                 <a:sym typeface="Open Sans Bold"/>
               </a:rPr>
-              <a:t>: 02</a:t>
+              <a:t>: [ESTEIRA</a:t>
             </a:r>
           </a:p>
         </p:txBody>
@@ -3787,6 +3784,1022 @@
 </file>
 
 <file path=ppt/slides/slide13.xml><?xml version="1.0" encoding="utf-8"?>
+<p:sld xmlns:a="http://schemas.openxmlformats.org/drawingml/2006/main" xmlns:r="http://schemas.openxmlformats.org/officeDocument/2006/relationships" xmlns:p="http://schemas.openxmlformats.org/presentationml/2006/main">
+  <p:cSld>
+    <p:spTree>
+      <p:nvGrpSpPr>
+        <p:cNvPr id="1" name=""/>
+        <p:cNvGrpSpPr/>
+        <p:nvPr/>
+      </p:nvGrpSpPr>
+      <p:grpSpPr>
+        <a:xfrm>
+          <a:off x="0" y="0"/>
+          <a:ext cx="0" cy="0"/>
+          <a:chOff x="0" y="0"/>
+          <a:chExt cx="0" cy="0"/>
+        </a:xfrm>
+      </p:grpSpPr>
+      <p:pic>
+        <p:nvPicPr>
+          <p:cNvPr id="3" name="Picture 2">
+            <a:extLst>
+              <a:ext uri="{FF2B5EF4-FFF2-40B4-BE49-F238E27FC236}">
+                <a16:creationId xmlns:a16="http://schemas.microsoft.com/office/drawing/2014/main" id="{662446C5-7AA1-0DE9-BE32-3044898050D0}"/>
+              </a:ext>
+            </a:extLst>
+          </p:cNvPr>
+          <p:cNvPicPr>
+            <a:picLocks noChangeAspect="1"/>
+          </p:cNvPicPr>
+          <p:nvPr/>
+        </p:nvPicPr>
+        <p:blipFill>
+          <a:blip r:embed="rId2">
+            <a:extLst>
+              <a:ext uri="{28A0092B-C50C-407E-A947-70E740481C1C}">
+                <a14:useLocalDpi xmlns:a14="http://schemas.microsoft.com/office/drawing/2010/main" val="0"/>
+              </a:ext>
+            </a:extLst>
+          </a:blip>
+          <a:stretch>
+            <a:fillRect/>
+          </a:stretch>
+        </p:blipFill>
+        <p:spPr>
+          <a:xfrm>
+            <a:off x="0" y="0"/>
+            <a:ext cx="18288000" cy="10287000"/>
+          </a:xfrm>
+          <a:prstGeom prst="rect">
+            <a:avLst/>
+          </a:prstGeom>
+        </p:spPr>
+      </p:pic>
+      <p:sp>
+        <p:nvSpPr>
+          <p:cNvPr id="11" name="TextBox 3">
+            <a:extLst>
+              <a:ext uri="{FF2B5EF4-FFF2-40B4-BE49-F238E27FC236}">
+                <a16:creationId xmlns:a16="http://schemas.microsoft.com/office/drawing/2014/main" id="{00D25E9D-CB8D-55DF-A742-FD3280B23F77}"/>
+              </a:ext>
+            </a:extLst>
+          </p:cNvPr>
+          <p:cNvSpPr txBox="1"/>
+          <p:nvPr/>
+        </p:nvSpPr>
+        <p:spPr>
+          <a:xfrm>
+            <a:off x="7696200" y="7658100"/>
+            <a:ext cx="11125200" cy="1041504"/>
+          </a:xfrm>
+          <a:prstGeom prst="rect">
+            <a:avLst/>
+          </a:prstGeom>
+        </p:spPr>
+        <p:txBody>
+          <a:bodyPr wrap="square" lIns="0" tIns="0" rIns="0" bIns="0" rtlCol="0" anchor="t">
+            <a:spAutoFit/>
+          </a:bodyPr>
+          <a:lstStyle/>
+          <a:p>
+            <a:pPr>
+              <a:lnSpc>
+                <a:spcPts val="8659"/>
+              </a:lnSpc>
+            </a:pPr>
+            <a:r>
+              <a:rPr lang="en-US" sz="6185" b="1" dirty="0" err="1">
+                <a:solidFill>
+                  <a:srgbClr val="FFFFFF"/>
+                </a:solidFill>
+                <a:latin typeface="Open Sans Bold"/>
+                <a:ea typeface="Open Sans Bold"/>
+                <a:cs typeface="Open Sans Bold"/>
+                <a:sym typeface="Open Sans Bold"/>
+              </a:rPr>
+              <a:t>Quantidade</a:t>
+            </a:r>
+            <a:r>
+              <a:rPr lang="en-US" sz="6185" b="1" dirty="0">
+                <a:solidFill>
+                  <a:srgbClr val="FFFFFF"/>
+                </a:solidFill>
+                <a:latin typeface="Open Sans Bold"/>
+                <a:ea typeface="Open Sans Bold"/>
+                <a:cs typeface="Open Sans Bold"/>
+                <a:sym typeface="Open Sans Bold"/>
+              </a:rPr>
+              <a:t>: [BIKE_KIKOS]</a:t>
+            </a:r>
+          </a:p>
+        </p:txBody>
+      </p:sp>
+    </p:spTree>
+  </p:cSld>
+  <p:clrMapOvr>
+    <a:masterClrMapping/>
+  </p:clrMapOvr>
+</p:sld>
+</file>
+
+<file path=ppt/slides/slide14.xml><?xml version="1.0" encoding="utf-8"?>
+<p:sld xmlns:a="http://schemas.openxmlformats.org/drawingml/2006/main" xmlns:r="http://schemas.openxmlformats.org/officeDocument/2006/relationships" xmlns:p="http://schemas.openxmlformats.org/presentationml/2006/main">
+  <p:cSld>
+    <p:spTree>
+      <p:nvGrpSpPr>
+        <p:cNvPr id="1" name=""/>
+        <p:cNvGrpSpPr/>
+        <p:nvPr/>
+      </p:nvGrpSpPr>
+      <p:grpSpPr>
+        <a:xfrm>
+          <a:off x="0" y="0"/>
+          <a:ext cx="0" cy="0"/>
+          <a:chOff x="0" y="0"/>
+          <a:chExt cx="0" cy="0"/>
+        </a:xfrm>
+      </p:grpSpPr>
+      <p:pic>
+        <p:nvPicPr>
+          <p:cNvPr id="5" name="Picture 4">
+            <a:extLst>
+              <a:ext uri="{FF2B5EF4-FFF2-40B4-BE49-F238E27FC236}">
+                <a16:creationId xmlns:a16="http://schemas.microsoft.com/office/drawing/2014/main" id="{B66300B2-8C1D-7104-206B-BD1F9407D5AC}"/>
+              </a:ext>
+            </a:extLst>
+          </p:cNvPr>
+          <p:cNvPicPr>
+            <a:picLocks noChangeAspect="1"/>
+          </p:cNvPicPr>
+          <p:nvPr/>
+        </p:nvPicPr>
+        <p:blipFill>
+          <a:blip r:embed="rId2">
+            <a:extLst>
+              <a:ext uri="{28A0092B-C50C-407E-A947-70E740481C1C}">
+                <a14:useLocalDpi xmlns:a14="http://schemas.microsoft.com/office/drawing/2010/main" val="0"/>
+              </a:ext>
+            </a:extLst>
+          </a:blip>
+          <a:stretch>
+            <a:fillRect/>
+          </a:stretch>
+        </p:blipFill>
+        <p:spPr>
+          <a:xfrm>
+            <a:off x="0" y="0"/>
+            <a:ext cx="18288000" cy="10287000"/>
+          </a:xfrm>
+          <a:prstGeom prst="rect">
+            <a:avLst/>
+          </a:prstGeom>
+        </p:spPr>
+      </p:pic>
+      <p:sp>
+        <p:nvSpPr>
+          <p:cNvPr id="3" name="TextBox 3"/>
+          <p:cNvSpPr txBox="1"/>
+          <p:nvPr/>
+        </p:nvSpPr>
+        <p:spPr>
+          <a:xfrm>
+            <a:off x="7239000" y="7581900"/>
+            <a:ext cx="12115800" cy="1041504"/>
+          </a:xfrm>
+          <a:prstGeom prst="rect">
+            <a:avLst/>
+          </a:prstGeom>
+        </p:spPr>
+        <p:txBody>
+          <a:bodyPr wrap="square" lIns="0" tIns="0" rIns="0" bIns="0" rtlCol="0" anchor="t">
+            <a:spAutoFit/>
+          </a:bodyPr>
+          <a:lstStyle/>
+          <a:p>
+            <a:pPr>
+              <a:lnSpc>
+                <a:spcPts val="8659"/>
+              </a:lnSpc>
+            </a:pPr>
+            <a:r>
+              <a:rPr lang="en-US" sz="6185" b="1" dirty="0" err="1">
+                <a:solidFill>
+                  <a:srgbClr val="FFFFFF"/>
+                </a:solidFill>
+                <a:latin typeface="Open Sans Bold"/>
+                <a:ea typeface="Open Sans Bold"/>
+                <a:cs typeface="Open Sans Bold"/>
+                <a:sym typeface="Open Sans Bold"/>
+              </a:rPr>
+              <a:t>Quantidade</a:t>
+            </a:r>
+            <a:r>
+              <a:rPr lang="en-US" sz="6185" b="1" dirty="0">
+                <a:solidFill>
+                  <a:srgbClr val="FFFFFF"/>
+                </a:solidFill>
+                <a:latin typeface="Open Sans Bold"/>
+                <a:ea typeface="Open Sans Bold"/>
+                <a:cs typeface="Open Sans Bold"/>
+                <a:sym typeface="Open Sans Bold"/>
+              </a:rPr>
+              <a:t>: [ESTACAO_MULT]</a:t>
+            </a:r>
+          </a:p>
+        </p:txBody>
+      </p:sp>
+    </p:spTree>
+  </p:cSld>
+  <p:clrMapOvr>
+    <a:masterClrMapping/>
+  </p:clrMapOvr>
+</p:sld>
+</file>
+
+<file path=ppt/slides/slide15.xml><?xml version="1.0" encoding="utf-8"?>
+<p:sld xmlns:a="http://schemas.openxmlformats.org/drawingml/2006/main" xmlns:r="http://schemas.openxmlformats.org/officeDocument/2006/relationships" xmlns:p="http://schemas.openxmlformats.org/presentationml/2006/main">
+  <p:cSld>
+    <p:spTree>
+      <p:nvGrpSpPr>
+        <p:cNvPr id="1" name=""/>
+        <p:cNvGrpSpPr/>
+        <p:nvPr/>
+      </p:nvGrpSpPr>
+      <p:grpSpPr>
+        <a:xfrm>
+          <a:off x="0" y="0"/>
+          <a:ext cx="0" cy="0"/>
+          <a:chOff x="0" y="0"/>
+          <a:chExt cx="0" cy="0"/>
+        </a:xfrm>
+      </p:grpSpPr>
+      <p:pic>
+        <p:nvPicPr>
+          <p:cNvPr id="5" name="Picture 4">
+            <a:extLst>
+              <a:ext uri="{FF2B5EF4-FFF2-40B4-BE49-F238E27FC236}">
+                <a16:creationId xmlns:a16="http://schemas.microsoft.com/office/drawing/2014/main" id="{8631FD8B-B785-64CB-F1E6-6269E6EB1DD9}"/>
+              </a:ext>
+            </a:extLst>
+          </p:cNvPr>
+          <p:cNvPicPr>
+            <a:picLocks noChangeAspect="1"/>
+          </p:cNvPicPr>
+          <p:nvPr/>
+        </p:nvPicPr>
+        <p:blipFill>
+          <a:blip r:embed="rId2">
+            <a:extLst>
+              <a:ext uri="{28A0092B-C50C-407E-A947-70E740481C1C}">
+                <a14:useLocalDpi xmlns:a14="http://schemas.microsoft.com/office/drawing/2010/main" val="0"/>
+              </a:ext>
+            </a:extLst>
+          </a:blip>
+          <a:stretch>
+            <a:fillRect/>
+          </a:stretch>
+        </p:blipFill>
+        <p:spPr>
+          <a:xfrm>
+            <a:off x="0" y="0"/>
+            <a:ext cx="18288000" cy="10287000"/>
+          </a:xfrm>
+          <a:prstGeom prst="rect">
+            <a:avLst/>
+          </a:prstGeom>
+        </p:spPr>
+      </p:pic>
+      <p:sp>
+        <p:nvSpPr>
+          <p:cNvPr id="3" name="TextBox 3"/>
+          <p:cNvSpPr txBox="1"/>
+          <p:nvPr/>
+        </p:nvSpPr>
+        <p:spPr>
+          <a:xfrm>
+            <a:off x="7772400" y="7658100"/>
+            <a:ext cx="11353800" cy="1041504"/>
+          </a:xfrm>
+          <a:prstGeom prst="rect">
+            <a:avLst/>
+          </a:prstGeom>
+        </p:spPr>
+        <p:txBody>
+          <a:bodyPr wrap="square" lIns="0" tIns="0" rIns="0" bIns="0" rtlCol="0" anchor="t">
+            <a:spAutoFit/>
+          </a:bodyPr>
+          <a:lstStyle/>
+          <a:p>
+            <a:pPr>
+              <a:lnSpc>
+                <a:spcPts val="8659"/>
+              </a:lnSpc>
+            </a:pPr>
+            <a:r>
+              <a:rPr lang="en-US" sz="6185" b="1" dirty="0" err="1">
+                <a:solidFill>
+                  <a:srgbClr val="FFFFFF"/>
+                </a:solidFill>
+                <a:latin typeface="Open Sans Bold"/>
+                <a:ea typeface="Open Sans Bold"/>
+                <a:cs typeface="Open Sans Bold"/>
+                <a:sym typeface="Open Sans Bold"/>
+              </a:rPr>
+              <a:t>Quantidade</a:t>
+            </a:r>
+            <a:r>
+              <a:rPr lang="en-US" sz="6185" b="1" dirty="0">
+                <a:solidFill>
+                  <a:srgbClr val="FFFFFF"/>
+                </a:solidFill>
+                <a:latin typeface="Open Sans Bold"/>
+                <a:ea typeface="Open Sans Bold"/>
+                <a:cs typeface="Open Sans Bold"/>
+                <a:sym typeface="Open Sans Bold"/>
+              </a:rPr>
+              <a:t>: [BANCO_MULT</a:t>
+            </a:r>
+          </a:p>
+        </p:txBody>
+      </p:sp>
+    </p:spTree>
+  </p:cSld>
+  <p:clrMapOvr>
+    <a:masterClrMapping/>
+  </p:clrMapOvr>
+</p:sld>
+</file>
+
+<file path=ppt/slides/slide16.xml><?xml version="1.0" encoding="utf-8"?>
+<p:sld xmlns:a="http://schemas.openxmlformats.org/drawingml/2006/main" xmlns:r="http://schemas.openxmlformats.org/officeDocument/2006/relationships" xmlns:p="http://schemas.openxmlformats.org/presentationml/2006/main">
+  <p:cSld>
+    <p:spTree>
+      <p:nvGrpSpPr>
+        <p:cNvPr id="1" name=""/>
+        <p:cNvGrpSpPr/>
+        <p:nvPr/>
+      </p:nvGrpSpPr>
+      <p:grpSpPr>
+        <a:xfrm>
+          <a:off x="0" y="0"/>
+          <a:ext cx="0" cy="0"/>
+          <a:chOff x="0" y="0"/>
+          <a:chExt cx="0" cy="0"/>
+        </a:xfrm>
+      </p:grpSpPr>
+      <p:pic>
+        <p:nvPicPr>
+          <p:cNvPr id="6" name="Picture 5">
+            <a:extLst>
+              <a:ext uri="{FF2B5EF4-FFF2-40B4-BE49-F238E27FC236}">
+                <a16:creationId xmlns:a16="http://schemas.microsoft.com/office/drawing/2014/main" id="{F16EF8C7-0E87-66FE-16B6-5D3F074C5EF6}"/>
+              </a:ext>
+            </a:extLst>
+          </p:cNvPr>
+          <p:cNvPicPr>
+            <a:picLocks noChangeAspect="1"/>
+          </p:cNvPicPr>
+          <p:nvPr/>
+        </p:nvPicPr>
+        <p:blipFill>
+          <a:blip r:embed="rId2">
+            <a:extLst>
+              <a:ext uri="{28A0092B-C50C-407E-A947-70E740481C1C}">
+                <a14:useLocalDpi xmlns:a14="http://schemas.microsoft.com/office/drawing/2010/main" val="0"/>
+              </a:ext>
+            </a:extLst>
+          </a:blip>
+          <a:stretch>
+            <a:fillRect/>
+          </a:stretch>
+        </p:blipFill>
+        <p:spPr>
+          <a:xfrm>
+            <a:off x="0" y="0"/>
+            <a:ext cx="18288000" cy="10287000"/>
+          </a:xfrm>
+          <a:prstGeom prst="rect">
+            <a:avLst/>
+          </a:prstGeom>
+        </p:spPr>
+      </p:pic>
+      <p:sp>
+        <p:nvSpPr>
+          <p:cNvPr id="3" name="TextBox 3"/>
+          <p:cNvSpPr txBox="1"/>
+          <p:nvPr/>
+        </p:nvSpPr>
+        <p:spPr>
+          <a:xfrm>
+            <a:off x="6172200" y="6155677"/>
+            <a:ext cx="10058400" cy="1041504"/>
+          </a:xfrm>
+          <a:prstGeom prst="rect">
+            <a:avLst/>
+          </a:prstGeom>
+        </p:spPr>
+        <p:txBody>
+          <a:bodyPr wrap="square" lIns="0" tIns="0" rIns="0" bIns="0" rtlCol="0" anchor="t">
+            <a:spAutoFit/>
+          </a:bodyPr>
+          <a:lstStyle/>
+          <a:p>
+            <a:pPr>
+              <a:lnSpc>
+                <a:spcPts val="8659"/>
+              </a:lnSpc>
+            </a:pPr>
+            <a:r>
+              <a:rPr lang="en-US" sz="6185" b="1" dirty="0" err="1">
+                <a:solidFill>
+                  <a:srgbClr val="FFFFFF"/>
+                </a:solidFill>
+                <a:latin typeface="Open Sans Bold"/>
+                <a:ea typeface="Open Sans Bold"/>
+                <a:cs typeface="Open Sans Bold"/>
+                <a:sym typeface="Open Sans Bold"/>
+              </a:rPr>
+              <a:t>Quantidade</a:t>
+            </a:r>
+            <a:r>
+              <a:rPr lang="en-US" sz="6185" b="1" dirty="0">
+                <a:solidFill>
+                  <a:srgbClr val="FFFFFF"/>
+                </a:solidFill>
+                <a:latin typeface="Open Sans Bold"/>
+                <a:ea typeface="Open Sans Bold"/>
+                <a:cs typeface="Open Sans Bold"/>
+                <a:sym typeface="Open Sans Bold"/>
+              </a:rPr>
+              <a:t>: [HALTER]</a:t>
+            </a:r>
+          </a:p>
+        </p:txBody>
+      </p:sp>
+      <p:sp>
+        <p:nvSpPr>
+          <p:cNvPr id="4" name="TextBox 4"/>
+          <p:cNvSpPr txBox="1"/>
+          <p:nvPr/>
+        </p:nvSpPr>
+        <p:spPr>
+          <a:xfrm>
+            <a:off x="6365299" y="8298802"/>
+            <a:ext cx="9408101" cy="1041504"/>
+          </a:xfrm>
+          <a:prstGeom prst="rect">
+            <a:avLst/>
+          </a:prstGeom>
+        </p:spPr>
+        <p:txBody>
+          <a:bodyPr wrap="square" lIns="0" tIns="0" rIns="0" bIns="0" rtlCol="0" anchor="t">
+            <a:spAutoFit/>
+          </a:bodyPr>
+          <a:lstStyle/>
+          <a:p>
+            <a:pPr>
+              <a:lnSpc>
+                <a:spcPts val="8659"/>
+              </a:lnSpc>
+            </a:pPr>
+            <a:r>
+              <a:rPr lang="en-US" sz="6185" b="1" dirty="0" err="1">
+                <a:solidFill>
+                  <a:srgbClr val="FFFFFF"/>
+                </a:solidFill>
+                <a:latin typeface="Open Sans Bold"/>
+                <a:ea typeface="Open Sans Bold"/>
+                <a:cs typeface="Open Sans Bold"/>
+                <a:sym typeface="Open Sans Bold"/>
+              </a:rPr>
+              <a:t>Quantidade</a:t>
+            </a:r>
+            <a:r>
+              <a:rPr lang="en-US" sz="6185" b="1" dirty="0">
+                <a:solidFill>
+                  <a:srgbClr val="FFFFFF"/>
+                </a:solidFill>
+                <a:latin typeface="Open Sans Bold"/>
+                <a:ea typeface="Open Sans Bold"/>
+                <a:cs typeface="Open Sans Bold"/>
+                <a:sym typeface="Open Sans Bold"/>
+              </a:rPr>
+              <a:t>: [ANILHA]</a:t>
+            </a:r>
+          </a:p>
+        </p:txBody>
+      </p:sp>
+    </p:spTree>
+  </p:cSld>
+  <p:clrMapOvr>
+    <a:masterClrMapping/>
+  </p:clrMapOvr>
+</p:sld>
+</file>
+
+<file path=ppt/slides/slide17.xml><?xml version="1.0" encoding="utf-8"?>
+<p:sld xmlns:a="http://schemas.openxmlformats.org/drawingml/2006/main" xmlns:r="http://schemas.openxmlformats.org/officeDocument/2006/relationships" xmlns:p="http://schemas.openxmlformats.org/presentationml/2006/main">
+  <p:cSld>
+    <p:spTree>
+      <p:nvGrpSpPr>
+        <p:cNvPr id="1" name=""/>
+        <p:cNvGrpSpPr/>
+        <p:nvPr/>
+      </p:nvGrpSpPr>
+      <p:grpSpPr>
+        <a:xfrm>
+          <a:off x="0" y="0"/>
+          <a:ext cx="0" cy="0"/>
+          <a:chOff x="0" y="0"/>
+          <a:chExt cx="0" cy="0"/>
+        </a:xfrm>
+      </p:grpSpPr>
+      <p:pic>
+        <p:nvPicPr>
+          <p:cNvPr id="5" name="Picture 4">
+            <a:extLst>
+              <a:ext uri="{FF2B5EF4-FFF2-40B4-BE49-F238E27FC236}">
+                <a16:creationId xmlns:a16="http://schemas.microsoft.com/office/drawing/2014/main" id="{CDEAC581-6BF0-D0F9-5400-9CCD99043F8B}"/>
+              </a:ext>
+            </a:extLst>
+          </p:cNvPr>
+          <p:cNvPicPr>
+            <a:picLocks noChangeAspect="1"/>
+          </p:cNvPicPr>
+          <p:nvPr/>
+        </p:nvPicPr>
+        <p:blipFill>
+          <a:blip r:embed="rId2">
+            <a:extLst>
+              <a:ext uri="{28A0092B-C50C-407E-A947-70E740481C1C}">
+                <a14:useLocalDpi xmlns:a14="http://schemas.microsoft.com/office/drawing/2010/main" val="0"/>
+              </a:ext>
+            </a:extLst>
+          </a:blip>
+          <a:stretch>
+            <a:fillRect/>
+          </a:stretch>
+        </p:blipFill>
+        <p:spPr>
+          <a:xfrm>
+            <a:off x="0" y="0"/>
+            <a:ext cx="18288000" cy="10287000"/>
+          </a:xfrm>
+          <a:prstGeom prst="rect">
+            <a:avLst/>
+          </a:prstGeom>
+        </p:spPr>
+      </p:pic>
+      <p:sp>
+        <p:nvSpPr>
+          <p:cNvPr id="3" name="TextBox 3"/>
+          <p:cNvSpPr txBox="1"/>
+          <p:nvPr/>
+        </p:nvSpPr>
+        <p:spPr>
+          <a:xfrm>
+            <a:off x="6705600" y="7658100"/>
+            <a:ext cx="9829800" cy="1041504"/>
+          </a:xfrm>
+          <a:prstGeom prst="rect">
+            <a:avLst/>
+          </a:prstGeom>
+        </p:spPr>
+        <p:txBody>
+          <a:bodyPr wrap="square" lIns="0" tIns="0" rIns="0" bIns="0" rtlCol="0" anchor="t">
+            <a:spAutoFit/>
+          </a:bodyPr>
+          <a:lstStyle/>
+          <a:p>
+            <a:pPr>
+              <a:lnSpc>
+                <a:spcPts val="8659"/>
+              </a:lnSpc>
+            </a:pPr>
+            <a:r>
+              <a:rPr lang="en-US" sz="6185" b="1" dirty="0" err="1">
+                <a:solidFill>
+                  <a:srgbClr val="FFFFFF"/>
+                </a:solidFill>
+                <a:latin typeface="Open Sans Bold"/>
+                <a:ea typeface="Open Sans Bold"/>
+                <a:cs typeface="Open Sans Bold"/>
+                <a:sym typeface="Open Sans Bold"/>
+              </a:rPr>
+              <a:t>Quantidade</a:t>
+            </a:r>
+            <a:r>
+              <a:rPr lang="en-US" sz="6185" b="1" dirty="0">
+                <a:solidFill>
+                  <a:srgbClr val="FFFFFF"/>
+                </a:solidFill>
+                <a:latin typeface="Open Sans Bold"/>
+                <a:ea typeface="Open Sans Bold"/>
+                <a:cs typeface="Open Sans Bold"/>
+                <a:sym typeface="Open Sans Bold"/>
+              </a:rPr>
+              <a:t>: [BARRA_W]</a:t>
+            </a:r>
+          </a:p>
+        </p:txBody>
+      </p:sp>
+    </p:spTree>
+  </p:cSld>
+  <p:clrMapOvr>
+    <a:masterClrMapping/>
+  </p:clrMapOvr>
+</p:sld>
+</file>
+
+<file path=ppt/slides/slide18.xml><?xml version="1.0" encoding="utf-8"?>
+<p:sld xmlns:a="http://schemas.openxmlformats.org/drawingml/2006/main" xmlns:r="http://schemas.openxmlformats.org/officeDocument/2006/relationships" xmlns:p="http://schemas.openxmlformats.org/presentationml/2006/main">
+  <p:cSld>
+    <p:spTree>
+      <p:nvGrpSpPr>
+        <p:cNvPr id="1" name=""/>
+        <p:cNvGrpSpPr/>
+        <p:nvPr/>
+      </p:nvGrpSpPr>
+      <p:grpSpPr>
+        <a:xfrm>
+          <a:off x="0" y="0"/>
+          <a:ext cx="0" cy="0"/>
+          <a:chOff x="0" y="0"/>
+          <a:chExt cx="0" cy="0"/>
+        </a:xfrm>
+      </p:grpSpPr>
+      <p:pic>
+        <p:nvPicPr>
+          <p:cNvPr id="6" name="Picture 5">
+            <a:extLst>
+              <a:ext uri="{FF2B5EF4-FFF2-40B4-BE49-F238E27FC236}">
+                <a16:creationId xmlns:a16="http://schemas.microsoft.com/office/drawing/2014/main" id="{4A5891F4-6D9E-B29A-DD4E-DE2D94173A73}"/>
+              </a:ext>
+            </a:extLst>
+          </p:cNvPr>
+          <p:cNvPicPr>
+            <a:picLocks noChangeAspect="1"/>
+          </p:cNvPicPr>
+          <p:nvPr/>
+        </p:nvPicPr>
+        <p:blipFill>
+          <a:blip r:embed="rId2">
+            <a:extLst>
+              <a:ext uri="{28A0092B-C50C-407E-A947-70E740481C1C}">
+                <a14:useLocalDpi xmlns:a14="http://schemas.microsoft.com/office/drawing/2010/main" val="0"/>
+              </a:ext>
+            </a:extLst>
+          </a:blip>
+          <a:stretch>
+            <a:fillRect/>
+          </a:stretch>
+        </p:blipFill>
+        <p:spPr>
+          <a:xfrm>
+            <a:off x="0" y="0"/>
+            <a:ext cx="18288000" cy="10287000"/>
+          </a:xfrm>
+          <a:prstGeom prst="rect">
+            <a:avLst/>
+          </a:prstGeom>
+        </p:spPr>
+      </p:pic>
+      <p:sp>
+        <p:nvSpPr>
+          <p:cNvPr id="3" name="TextBox 3"/>
+          <p:cNvSpPr txBox="1"/>
+          <p:nvPr/>
+        </p:nvSpPr>
+        <p:spPr>
+          <a:xfrm>
+            <a:off x="5867400" y="6210300"/>
+            <a:ext cx="10820400" cy="1041504"/>
+          </a:xfrm>
+          <a:prstGeom prst="rect">
+            <a:avLst/>
+          </a:prstGeom>
+        </p:spPr>
+        <p:txBody>
+          <a:bodyPr wrap="square" lIns="0" tIns="0" rIns="0" bIns="0" rtlCol="0" anchor="t">
+            <a:spAutoFit/>
+          </a:bodyPr>
+          <a:lstStyle/>
+          <a:p>
+            <a:pPr>
+              <a:lnSpc>
+                <a:spcPts val="8659"/>
+              </a:lnSpc>
+            </a:pPr>
+            <a:r>
+              <a:rPr lang="en-US" sz="6185" b="1" dirty="0" err="1">
+                <a:solidFill>
+                  <a:srgbClr val="FFFFFF"/>
+                </a:solidFill>
+                <a:latin typeface="Open Sans Bold"/>
+                <a:ea typeface="Open Sans Bold"/>
+                <a:cs typeface="Open Sans Bold"/>
+                <a:sym typeface="Open Sans Bold"/>
+              </a:rPr>
+              <a:t>Quantidade</a:t>
+            </a:r>
+            <a:r>
+              <a:rPr lang="en-US" sz="6185" b="1" dirty="0">
+                <a:solidFill>
+                  <a:srgbClr val="FFFFFF"/>
+                </a:solidFill>
+                <a:latin typeface="Open Sans Bold"/>
+                <a:ea typeface="Open Sans Bold"/>
+                <a:cs typeface="Open Sans Bold"/>
+                <a:sym typeface="Open Sans Bold"/>
+              </a:rPr>
+              <a:t>: [SUP_BARRA]</a:t>
+            </a:r>
+          </a:p>
+        </p:txBody>
+      </p:sp>
+      <p:sp>
+        <p:nvSpPr>
+          <p:cNvPr id="4" name="TextBox 4"/>
+          <p:cNvSpPr txBox="1"/>
+          <p:nvPr/>
+        </p:nvSpPr>
+        <p:spPr>
+          <a:xfrm>
+            <a:off x="5791200" y="8246790"/>
+            <a:ext cx="11049000" cy="1041504"/>
+          </a:xfrm>
+          <a:prstGeom prst="rect">
+            <a:avLst/>
+          </a:prstGeom>
+        </p:spPr>
+        <p:txBody>
+          <a:bodyPr wrap="square" lIns="0" tIns="0" rIns="0" bIns="0" rtlCol="0" anchor="t">
+            <a:spAutoFit/>
+          </a:bodyPr>
+          <a:lstStyle/>
+          <a:p>
+            <a:pPr>
+              <a:lnSpc>
+                <a:spcPts val="8659"/>
+              </a:lnSpc>
+            </a:pPr>
+            <a:r>
+              <a:rPr lang="en-US" sz="6185" b="1" dirty="0" err="1">
+                <a:solidFill>
+                  <a:srgbClr val="FFFFFF"/>
+                </a:solidFill>
+                <a:latin typeface="Open Sans Bold"/>
+                <a:ea typeface="Open Sans Bold"/>
+                <a:cs typeface="Open Sans Bold"/>
+                <a:sym typeface="Open Sans Bold"/>
+              </a:rPr>
+              <a:t>Quantidade</a:t>
+            </a:r>
+            <a:r>
+              <a:rPr lang="en-US" sz="6185" b="1" dirty="0">
+                <a:solidFill>
+                  <a:srgbClr val="FFFFFF"/>
+                </a:solidFill>
+                <a:latin typeface="Open Sans Bold"/>
+                <a:ea typeface="Open Sans Bold"/>
+                <a:cs typeface="Open Sans Bold"/>
+                <a:sym typeface="Open Sans Bold"/>
+              </a:rPr>
+              <a:t>: [SUP_HALTER]</a:t>
+            </a:r>
+          </a:p>
+        </p:txBody>
+      </p:sp>
+    </p:spTree>
+  </p:cSld>
+  <p:clrMapOvr>
+    <a:masterClrMapping/>
+  </p:clrMapOvr>
+</p:sld>
+</file>
+
+<file path=ppt/slides/slide19.xml><?xml version="1.0" encoding="utf-8"?>
+<p:sld xmlns:a="http://schemas.openxmlformats.org/drawingml/2006/main" xmlns:r="http://schemas.openxmlformats.org/officeDocument/2006/relationships" xmlns:p="http://schemas.openxmlformats.org/presentationml/2006/main">
+  <p:cSld>
+    <p:spTree>
+      <p:nvGrpSpPr>
+        <p:cNvPr id="1" name=""/>
+        <p:cNvGrpSpPr/>
+        <p:nvPr/>
+      </p:nvGrpSpPr>
+      <p:grpSpPr>
+        <a:xfrm>
+          <a:off x="0" y="0"/>
+          <a:ext cx="0" cy="0"/>
+          <a:chOff x="0" y="0"/>
+          <a:chExt cx="0" cy="0"/>
+        </a:xfrm>
+      </p:grpSpPr>
+      <p:pic>
+        <p:nvPicPr>
+          <p:cNvPr id="7" name="Picture 6">
+            <a:extLst>
+              <a:ext uri="{FF2B5EF4-FFF2-40B4-BE49-F238E27FC236}">
+                <a16:creationId xmlns:a16="http://schemas.microsoft.com/office/drawing/2014/main" id="{C8F0A85E-49CB-881A-28A0-E946A223BB39}"/>
+              </a:ext>
+            </a:extLst>
+          </p:cNvPr>
+          <p:cNvPicPr>
+            <a:picLocks noChangeAspect="1"/>
+          </p:cNvPicPr>
+          <p:nvPr/>
+        </p:nvPicPr>
+        <p:blipFill>
+          <a:blip r:embed="rId2">
+            <a:extLst>
+              <a:ext uri="{28A0092B-C50C-407E-A947-70E740481C1C}">
+                <a14:useLocalDpi xmlns:a14="http://schemas.microsoft.com/office/drawing/2010/main" val="0"/>
+              </a:ext>
+            </a:extLst>
+          </a:blip>
+          <a:stretch>
+            <a:fillRect/>
+          </a:stretch>
+        </p:blipFill>
+        <p:spPr>
+          <a:xfrm>
+            <a:off x="0" y="0"/>
+            <a:ext cx="18288000" cy="10287000"/>
+          </a:xfrm>
+          <a:prstGeom prst="rect">
+            <a:avLst/>
+          </a:prstGeom>
+        </p:spPr>
+      </p:pic>
+      <p:sp>
+        <p:nvSpPr>
+          <p:cNvPr id="3" name="TextBox 3"/>
+          <p:cNvSpPr txBox="1"/>
+          <p:nvPr/>
+        </p:nvSpPr>
+        <p:spPr>
+          <a:xfrm>
+            <a:off x="7519885" y="5270903"/>
+            <a:ext cx="8558315" cy="854721"/>
+          </a:xfrm>
+          <a:prstGeom prst="rect">
+            <a:avLst/>
+          </a:prstGeom>
+        </p:spPr>
+        <p:txBody>
+          <a:bodyPr wrap="square" lIns="0" tIns="0" rIns="0" bIns="0" rtlCol="0" anchor="t">
+            <a:spAutoFit/>
+          </a:bodyPr>
+          <a:lstStyle/>
+          <a:p>
+            <a:pPr>
+              <a:lnSpc>
+                <a:spcPts val="7212"/>
+              </a:lnSpc>
+            </a:pPr>
+            <a:r>
+              <a:rPr lang="en-US" sz="4900" b="1" dirty="0" err="1">
+                <a:solidFill>
+                  <a:srgbClr val="FFFFFF"/>
+                </a:solidFill>
+                <a:latin typeface="Open Sans Bold"/>
+                <a:ea typeface="Open Sans Bold"/>
+                <a:cs typeface="Open Sans Bold"/>
+                <a:sym typeface="Open Sans Bold"/>
+              </a:rPr>
+              <a:t>Quantidade</a:t>
+            </a:r>
+            <a:r>
+              <a:rPr lang="en-US" sz="4900" b="1" dirty="0">
+                <a:solidFill>
+                  <a:srgbClr val="FFFFFF"/>
+                </a:solidFill>
+                <a:latin typeface="Open Sans Bold"/>
+                <a:ea typeface="Open Sans Bold"/>
+                <a:cs typeface="Open Sans Bold"/>
+                <a:sym typeface="Open Sans Bold"/>
+              </a:rPr>
+              <a:t>: [TRI_SERG]</a:t>
+            </a:r>
+          </a:p>
+        </p:txBody>
+      </p:sp>
+      <p:sp>
+        <p:nvSpPr>
+          <p:cNvPr id="4" name="TextBox 4"/>
+          <p:cNvSpPr txBox="1"/>
+          <p:nvPr/>
+        </p:nvSpPr>
+        <p:spPr>
+          <a:xfrm>
+            <a:off x="8229600" y="7130499"/>
+            <a:ext cx="8915400" cy="854721"/>
+          </a:xfrm>
+          <a:prstGeom prst="rect">
+            <a:avLst/>
+          </a:prstGeom>
+        </p:spPr>
+        <p:txBody>
+          <a:bodyPr wrap="square" lIns="0" tIns="0" rIns="0" bIns="0" rtlCol="0" anchor="t">
+            <a:spAutoFit/>
+          </a:bodyPr>
+          <a:lstStyle/>
+          <a:p>
+            <a:pPr>
+              <a:lnSpc>
+                <a:spcPts val="7212"/>
+              </a:lnSpc>
+            </a:pPr>
+            <a:r>
+              <a:rPr lang="en-US" sz="4900" b="1" dirty="0" err="1">
+                <a:solidFill>
+                  <a:srgbClr val="FFFFFF"/>
+                </a:solidFill>
+                <a:latin typeface="Open Sans Bold"/>
+                <a:ea typeface="Open Sans Bold"/>
+                <a:cs typeface="Open Sans Bold"/>
+                <a:sym typeface="Open Sans Bold"/>
+              </a:rPr>
+              <a:t>Quantidade</a:t>
+            </a:r>
+            <a:r>
+              <a:rPr lang="en-US" sz="4900" b="1" dirty="0">
+                <a:solidFill>
+                  <a:srgbClr val="FFFFFF"/>
+                </a:solidFill>
+                <a:latin typeface="Open Sans Bold"/>
+                <a:ea typeface="Open Sans Bold"/>
+                <a:cs typeface="Open Sans Bold"/>
+                <a:sym typeface="Open Sans Bold"/>
+              </a:rPr>
+              <a:t>: [CORDA_SERG]</a:t>
+            </a:r>
+          </a:p>
+        </p:txBody>
+      </p:sp>
+      <p:sp>
+        <p:nvSpPr>
+          <p:cNvPr id="5" name="TextBox 5"/>
+          <p:cNvSpPr txBox="1"/>
+          <p:nvPr/>
+        </p:nvSpPr>
+        <p:spPr>
+          <a:xfrm>
+            <a:off x="8610600" y="8913179"/>
+            <a:ext cx="8534400" cy="878521"/>
+          </a:xfrm>
+          <a:prstGeom prst="rect">
+            <a:avLst/>
+          </a:prstGeom>
+        </p:spPr>
+        <p:txBody>
+          <a:bodyPr wrap="square" lIns="0" tIns="0" rIns="0" bIns="0" rtlCol="0" anchor="t">
+            <a:spAutoFit/>
+          </a:bodyPr>
+          <a:lstStyle/>
+          <a:p>
+            <a:pPr>
+              <a:lnSpc>
+                <a:spcPts val="7212"/>
+              </a:lnSpc>
+            </a:pPr>
+            <a:r>
+              <a:rPr lang="en-US" sz="4900" b="1" dirty="0" err="1">
+                <a:solidFill>
+                  <a:srgbClr val="FFFFFF"/>
+                </a:solidFill>
+                <a:latin typeface="Open Sans Bold"/>
+                <a:ea typeface="Open Sans Bold"/>
+                <a:cs typeface="Open Sans Bold"/>
+                <a:sym typeface="Open Sans Bold"/>
+              </a:rPr>
+              <a:t>Quantidade</a:t>
+            </a:r>
+            <a:r>
+              <a:rPr lang="en-US" sz="4900" b="1" dirty="0">
+                <a:solidFill>
+                  <a:srgbClr val="FFFFFF"/>
+                </a:solidFill>
+                <a:latin typeface="Open Sans Bold"/>
+                <a:ea typeface="Open Sans Bold"/>
+                <a:cs typeface="Open Sans Bold"/>
+                <a:sym typeface="Open Sans Bold"/>
+              </a:rPr>
+              <a:t>: [PUX_ROMA]</a:t>
+            </a:r>
+          </a:p>
+        </p:txBody>
+      </p:sp>
+    </p:spTree>
+  </p:cSld>
+  <p:clrMapOvr>
+    <a:masterClrMapping/>
+  </p:clrMapOvr>
+</p:sld>
+</file>
+
+<file path=ppt/slides/slide2.xml><?xml version="1.0" encoding="utf-8"?>
 <p:sld xmlns:a="http://schemas.openxmlformats.org/drawingml/2006/main" xmlns:r="http://schemas.openxmlformats.org/officeDocument/2006/relationships" xmlns:p="http://schemas.openxmlformats.org/presentationml/2006/main">
   <p:cSld>
     <p:spTree>
@@ -3849,927 +4862,6 @@
           </a:blipFill>
         </p:spPr>
       </p:sp>
-      <p:sp>
-        <p:nvSpPr>
-          <p:cNvPr id="3" name="TextBox 3"/>
-          <p:cNvSpPr txBox="1"/>
-          <p:nvPr/>
-        </p:nvSpPr>
-        <p:spPr>
-          <a:xfrm>
-            <a:off x="9144000" y="7636273"/>
-            <a:ext cx="6553200" cy="1045223"/>
-          </a:xfrm>
-          <a:prstGeom prst="rect">
-            <a:avLst/>
-          </a:prstGeom>
-        </p:spPr>
-        <p:txBody>
-          <a:bodyPr wrap="square" lIns="0" tIns="0" rIns="0" bIns="0" rtlCol="0" anchor="t">
-            <a:spAutoFit/>
-          </a:bodyPr>
-          <a:lstStyle/>
-          <a:p>
-            <a:pPr algn="ctr">
-              <a:lnSpc>
-                <a:spcPts val="8659"/>
-              </a:lnSpc>
-            </a:pPr>
-            <a:r>
-              <a:rPr lang="en-US" sz="6185" b="1" dirty="0" err="1">
-                <a:solidFill>
-                  <a:srgbClr val="FFFFFF"/>
-                </a:solidFill>
-                <a:latin typeface="Open Sans Bold"/>
-                <a:ea typeface="Open Sans Bold"/>
-                <a:cs typeface="Open Sans Bold"/>
-                <a:sym typeface="Open Sans Bold"/>
-              </a:rPr>
-              <a:t>Quantidade</a:t>
-            </a:r>
-            <a:r>
-              <a:rPr lang="en-US" sz="6185" b="1" dirty="0">
-                <a:solidFill>
-                  <a:srgbClr val="FFFFFF"/>
-                </a:solidFill>
-                <a:latin typeface="Open Sans Bold"/>
-                <a:ea typeface="Open Sans Bold"/>
-                <a:cs typeface="Open Sans Bold"/>
-                <a:sym typeface="Open Sans Bold"/>
-              </a:rPr>
-              <a:t>: 01</a:t>
-            </a:r>
-          </a:p>
-        </p:txBody>
-      </p:sp>
-    </p:spTree>
-  </p:cSld>
-  <p:clrMapOvr>
-    <a:masterClrMapping/>
-  </p:clrMapOvr>
-</p:sld>
-</file>
-
-<file path=ppt/slides/slide14.xml><?xml version="1.0" encoding="utf-8"?>
-<p:sld xmlns:a="http://schemas.openxmlformats.org/drawingml/2006/main" xmlns:r="http://schemas.openxmlformats.org/officeDocument/2006/relationships" xmlns:p="http://schemas.openxmlformats.org/presentationml/2006/main">
-  <p:cSld>
-    <p:spTree>
-      <p:nvGrpSpPr>
-        <p:cNvPr id="1" name=""/>
-        <p:cNvGrpSpPr/>
-        <p:nvPr/>
-      </p:nvGrpSpPr>
-      <p:grpSpPr>
-        <a:xfrm>
-          <a:off x="0" y="0"/>
-          <a:ext cx="0" cy="0"/>
-          <a:chOff x="0" y="0"/>
-          <a:chExt cx="0" cy="0"/>
-        </a:xfrm>
-      </p:grpSpPr>
-      <p:sp>
-        <p:nvSpPr>
-          <p:cNvPr id="2" name="Freeform 2"/>
-          <p:cNvSpPr/>
-          <p:nvPr/>
-        </p:nvSpPr>
-        <p:spPr>
-          <a:xfrm>
-            <a:off x="0" y="0"/>
-            <a:ext cx="18288000" cy="10287000"/>
-          </a:xfrm>
-          <a:custGeom>
-            <a:avLst/>
-            <a:gdLst/>
-            <a:ahLst/>
-            <a:cxnLst/>
-            <a:rect l="l" t="t" r="r" b="b"/>
-            <a:pathLst>
-              <a:path w="18288000" h="10287000">
-                <a:moveTo>
-                  <a:pt x="0" y="0"/>
-                </a:moveTo>
-                <a:lnTo>
-                  <a:pt x="18288000" y="0"/>
-                </a:lnTo>
-                <a:lnTo>
-                  <a:pt x="18288000" y="10287000"/>
-                </a:lnTo>
-                <a:lnTo>
-                  <a:pt x="0" y="10287000"/>
-                </a:lnTo>
-                <a:lnTo>
-                  <a:pt x="0" y="0"/>
-                </a:lnTo>
-                <a:close/>
-              </a:path>
-            </a:pathLst>
-          </a:custGeom>
-          <a:blipFill>
-            <a:blip r:embed="rId2"/>
-            <a:stretch>
-              <a:fillRect/>
-            </a:stretch>
-          </a:blipFill>
-        </p:spPr>
-      </p:sp>
-      <p:sp>
-        <p:nvSpPr>
-          <p:cNvPr id="3" name="TextBox 3"/>
-          <p:cNvSpPr txBox="1"/>
-          <p:nvPr/>
-        </p:nvSpPr>
-        <p:spPr>
-          <a:xfrm>
-            <a:off x="8743916" y="8892868"/>
-            <a:ext cx="6877084" cy="1045223"/>
-          </a:xfrm>
-          <a:prstGeom prst="rect">
-            <a:avLst/>
-          </a:prstGeom>
-        </p:spPr>
-        <p:txBody>
-          <a:bodyPr wrap="square" lIns="0" tIns="0" rIns="0" bIns="0" rtlCol="0" anchor="t">
-            <a:spAutoFit/>
-          </a:bodyPr>
-          <a:lstStyle/>
-          <a:p>
-            <a:pPr algn="ctr">
-              <a:lnSpc>
-                <a:spcPts val="8659"/>
-              </a:lnSpc>
-            </a:pPr>
-            <a:r>
-              <a:rPr lang="en-US" sz="6185" b="1" dirty="0" err="1">
-                <a:solidFill>
-                  <a:srgbClr val="FFFFFF"/>
-                </a:solidFill>
-                <a:latin typeface="Open Sans Bold"/>
-                <a:ea typeface="Open Sans Bold"/>
-                <a:cs typeface="Open Sans Bold"/>
-                <a:sym typeface="Open Sans Bold"/>
-              </a:rPr>
-              <a:t>Quantidade</a:t>
-            </a:r>
-            <a:r>
-              <a:rPr lang="en-US" sz="6185" b="1" dirty="0">
-                <a:solidFill>
-                  <a:srgbClr val="FFFFFF"/>
-                </a:solidFill>
-                <a:latin typeface="Open Sans Bold"/>
-                <a:ea typeface="Open Sans Bold"/>
-                <a:cs typeface="Open Sans Bold"/>
-                <a:sym typeface="Open Sans Bold"/>
-              </a:rPr>
-              <a:t>: 01</a:t>
-            </a:r>
-          </a:p>
-        </p:txBody>
-      </p:sp>
-    </p:spTree>
-  </p:cSld>
-  <p:clrMapOvr>
-    <a:masterClrMapping/>
-  </p:clrMapOvr>
-</p:sld>
-</file>
-
-<file path=ppt/slides/slide15.xml><?xml version="1.0" encoding="utf-8"?>
-<p:sld xmlns:a="http://schemas.openxmlformats.org/drawingml/2006/main" xmlns:r="http://schemas.openxmlformats.org/officeDocument/2006/relationships" xmlns:p="http://schemas.openxmlformats.org/presentationml/2006/main">
-  <p:cSld>
-    <p:spTree>
-      <p:nvGrpSpPr>
-        <p:cNvPr id="1" name=""/>
-        <p:cNvGrpSpPr/>
-        <p:nvPr/>
-      </p:nvGrpSpPr>
-      <p:grpSpPr>
-        <a:xfrm>
-          <a:off x="0" y="0"/>
-          <a:ext cx="0" cy="0"/>
-          <a:chOff x="0" y="0"/>
-          <a:chExt cx="0" cy="0"/>
-        </a:xfrm>
-      </p:grpSpPr>
-      <p:sp>
-        <p:nvSpPr>
-          <p:cNvPr id="2" name="Freeform 2"/>
-          <p:cNvSpPr/>
-          <p:nvPr/>
-        </p:nvSpPr>
-        <p:spPr>
-          <a:xfrm>
-            <a:off x="0" y="0"/>
-            <a:ext cx="18288000" cy="10287000"/>
-          </a:xfrm>
-          <a:custGeom>
-            <a:avLst/>
-            <a:gdLst/>
-            <a:ahLst/>
-            <a:cxnLst/>
-            <a:rect l="l" t="t" r="r" b="b"/>
-            <a:pathLst>
-              <a:path w="18288000" h="10287000">
-                <a:moveTo>
-                  <a:pt x="0" y="0"/>
-                </a:moveTo>
-                <a:lnTo>
-                  <a:pt x="18288000" y="0"/>
-                </a:lnTo>
-                <a:lnTo>
-                  <a:pt x="18288000" y="10287000"/>
-                </a:lnTo>
-                <a:lnTo>
-                  <a:pt x="0" y="10287000"/>
-                </a:lnTo>
-                <a:lnTo>
-                  <a:pt x="0" y="0"/>
-                </a:lnTo>
-                <a:close/>
-              </a:path>
-            </a:pathLst>
-          </a:custGeom>
-          <a:blipFill>
-            <a:blip r:embed="rId2"/>
-            <a:stretch>
-              <a:fillRect/>
-            </a:stretch>
-          </a:blipFill>
-        </p:spPr>
-      </p:sp>
-      <p:sp>
-        <p:nvSpPr>
-          <p:cNvPr id="3" name="TextBox 3"/>
-          <p:cNvSpPr txBox="1"/>
-          <p:nvPr/>
-        </p:nvSpPr>
-        <p:spPr>
-          <a:xfrm>
-            <a:off x="9144000" y="7636273"/>
-            <a:ext cx="6934200" cy="1045223"/>
-          </a:xfrm>
-          <a:prstGeom prst="rect">
-            <a:avLst/>
-          </a:prstGeom>
-        </p:spPr>
-        <p:txBody>
-          <a:bodyPr wrap="square" lIns="0" tIns="0" rIns="0" bIns="0" rtlCol="0" anchor="t">
-            <a:spAutoFit/>
-          </a:bodyPr>
-          <a:lstStyle/>
-          <a:p>
-            <a:pPr algn="ctr">
-              <a:lnSpc>
-                <a:spcPts val="8659"/>
-              </a:lnSpc>
-            </a:pPr>
-            <a:r>
-              <a:rPr lang="en-US" sz="6185" b="1" dirty="0" err="1">
-                <a:solidFill>
-                  <a:srgbClr val="FFFFFF"/>
-                </a:solidFill>
-                <a:latin typeface="Open Sans Bold"/>
-                <a:ea typeface="Open Sans Bold"/>
-                <a:cs typeface="Open Sans Bold"/>
-                <a:sym typeface="Open Sans Bold"/>
-              </a:rPr>
-              <a:t>Quantidade</a:t>
-            </a:r>
-            <a:r>
-              <a:rPr lang="en-US" sz="6185" b="1" dirty="0">
-                <a:solidFill>
-                  <a:srgbClr val="FFFFFF"/>
-                </a:solidFill>
-                <a:latin typeface="Open Sans Bold"/>
-                <a:ea typeface="Open Sans Bold"/>
-                <a:cs typeface="Open Sans Bold"/>
-                <a:sym typeface="Open Sans Bold"/>
-              </a:rPr>
-              <a:t>: 01</a:t>
-            </a:r>
-          </a:p>
-        </p:txBody>
-      </p:sp>
-    </p:spTree>
-  </p:cSld>
-  <p:clrMapOvr>
-    <a:masterClrMapping/>
-  </p:clrMapOvr>
-</p:sld>
-</file>
-
-<file path=ppt/slides/slide16.xml><?xml version="1.0" encoding="utf-8"?>
-<p:sld xmlns:a="http://schemas.openxmlformats.org/drawingml/2006/main" xmlns:r="http://schemas.openxmlformats.org/officeDocument/2006/relationships" xmlns:p="http://schemas.openxmlformats.org/presentationml/2006/main">
-  <p:cSld>
-    <p:spTree>
-      <p:nvGrpSpPr>
-        <p:cNvPr id="1" name=""/>
-        <p:cNvGrpSpPr/>
-        <p:nvPr/>
-      </p:nvGrpSpPr>
-      <p:grpSpPr>
-        <a:xfrm>
-          <a:off x="0" y="0"/>
-          <a:ext cx="0" cy="0"/>
-          <a:chOff x="0" y="0"/>
-          <a:chExt cx="0" cy="0"/>
-        </a:xfrm>
-      </p:grpSpPr>
-      <p:sp>
-        <p:nvSpPr>
-          <p:cNvPr id="2" name="Freeform 2"/>
-          <p:cNvSpPr/>
-          <p:nvPr/>
-        </p:nvSpPr>
-        <p:spPr>
-          <a:xfrm>
-            <a:off x="0" y="0"/>
-            <a:ext cx="18288000" cy="10287000"/>
-          </a:xfrm>
-          <a:custGeom>
-            <a:avLst/>
-            <a:gdLst/>
-            <a:ahLst/>
-            <a:cxnLst/>
-            <a:rect l="l" t="t" r="r" b="b"/>
-            <a:pathLst>
-              <a:path w="18288000" h="10287000">
-                <a:moveTo>
-                  <a:pt x="0" y="0"/>
-                </a:moveTo>
-                <a:lnTo>
-                  <a:pt x="18288000" y="0"/>
-                </a:lnTo>
-                <a:lnTo>
-                  <a:pt x="18288000" y="10287000"/>
-                </a:lnTo>
-                <a:lnTo>
-                  <a:pt x="0" y="10287000"/>
-                </a:lnTo>
-                <a:lnTo>
-                  <a:pt x="0" y="0"/>
-                </a:lnTo>
-                <a:close/>
-              </a:path>
-            </a:pathLst>
-          </a:custGeom>
-          <a:blipFill>
-            <a:blip r:embed="rId2"/>
-            <a:stretch>
-              <a:fillRect/>
-            </a:stretch>
-          </a:blipFill>
-        </p:spPr>
-      </p:sp>
-      <p:sp>
-        <p:nvSpPr>
-          <p:cNvPr id="3" name="TextBox 3"/>
-          <p:cNvSpPr txBox="1"/>
-          <p:nvPr/>
-        </p:nvSpPr>
-        <p:spPr>
-          <a:xfrm>
-            <a:off x="9144000" y="7636273"/>
-            <a:ext cx="7391400" cy="1045223"/>
-          </a:xfrm>
-          <a:prstGeom prst="rect">
-            <a:avLst/>
-          </a:prstGeom>
-        </p:spPr>
-        <p:txBody>
-          <a:bodyPr wrap="square" lIns="0" tIns="0" rIns="0" bIns="0" rtlCol="0" anchor="t">
-            <a:spAutoFit/>
-          </a:bodyPr>
-          <a:lstStyle/>
-          <a:p>
-            <a:pPr algn="ctr">
-              <a:lnSpc>
-                <a:spcPts val="8659"/>
-              </a:lnSpc>
-            </a:pPr>
-            <a:r>
-              <a:rPr lang="en-US" sz="6185" b="1" dirty="0" err="1">
-                <a:solidFill>
-                  <a:srgbClr val="FFFFFF"/>
-                </a:solidFill>
-                <a:latin typeface="Open Sans Bold"/>
-                <a:ea typeface="Open Sans Bold"/>
-                <a:cs typeface="Open Sans Bold"/>
-                <a:sym typeface="Open Sans Bold"/>
-              </a:rPr>
-              <a:t>Quantidade</a:t>
-            </a:r>
-            <a:r>
-              <a:rPr lang="en-US" sz="6185" b="1" dirty="0">
-                <a:solidFill>
-                  <a:srgbClr val="FFFFFF"/>
-                </a:solidFill>
-                <a:latin typeface="Open Sans Bold"/>
-                <a:ea typeface="Open Sans Bold"/>
-                <a:cs typeface="Open Sans Bold"/>
-                <a:sym typeface="Open Sans Bold"/>
-              </a:rPr>
-              <a:t>: 01</a:t>
-            </a:r>
-          </a:p>
-        </p:txBody>
-      </p:sp>
-    </p:spTree>
-  </p:cSld>
-  <p:clrMapOvr>
-    <a:masterClrMapping/>
-  </p:clrMapOvr>
-</p:sld>
-</file>
-
-<file path=ppt/slides/slide17.xml><?xml version="1.0" encoding="utf-8"?>
-<p:sld xmlns:a="http://schemas.openxmlformats.org/drawingml/2006/main" xmlns:r="http://schemas.openxmlformats.org/officeDocument/2006/relationships" xmlns:p="http://schemas.openxmlformats.org/presentationml/2006/main">
-  <p:cSld>
-    <p:spTree>
-      <p:nvGrpSpPr>
-        <p:cNvPr id="1" name=""/>
-        <p:cNvGrpSpPr/>
-        <p:nvPr/>
-      </p:nvGrpSpPr>
-      <p:grpSpPr>
-        <a:xfrm>
-          <a:off x="0" y="0"/>
-          <a:ext cx="0" cy="0"/>
-          <a:chOff x="0" y="0"/>
-          <a:chExt cx="0" cy="0"/>
-        </a:xfrm>
-      </p:grpSpPr>
-      <p:sp>
-        <p:nvSpPr>
-          <p:cNvPr id="2" name="Freeform 2"/>
-          <p:cNvSpPr/>
-          <p:nvPr/>
-        </p:nvSpPr>
-        <p:spPr>
-          <a:xfrm>
-            <a:off x="0" y="0"/>
-            <a:ext cx="18288000" cy="10287000"/>
-          </a:xfrm>
-          <a:custGeom>
-            <a:avLst/>
-            <a:gdLst/>
-            <a:ahLst/>
-            <a:cxnLst/>
-            <a:rect l="l" t="t" r="r" b="b"/>
-            <a:pathLst>
-              <a:path w="18288000" h="10287000">
-                <a:moveTo>
-                  <a:pt x="0" y="0"/>
-                </a:moveTo>
-                <a:lnTo>
-                  <a:pt x="18288000" y="0"/>
-                </a:lnTo>
-                <a:lnTo>
-                  <a:pt x="18288000" y="10287000"/>
-                </a:lnTo>
-                <a:lnTo>
-                  <a:pt x="0" y="10287000"/>
-                </a:lnTo>
-                <a:lnTo>
-                  <a:pt x="0" y="0"/>
-                </a:lnTo>
-                <a:close/>
-              </a:path>
-            </a:pathLst>
-          </a:custGeom>
-          <a:blipFill>
-            <a:blip r:embed="rId2"/>
-            <a:stretch>
-              <a:fillRect/>
-            </a:stretch>
-          </a:blipFill>
-        </p:spPr>
-      </p:sp>
-      <p:sp>
-        <p:nvSpPr>
-          <p:cNvPr id="3" name="TextBox 3"/>
-          <p:cNvSpPr txBox="1"/>
-          <p:nvPr/>
-        </p:nvSpPr>
-        <p:spPr>
-          <a:xfrm>
-            <a:off x="9144000" y="7636273"/>
-            <a:ext cx="7162800" cy="1045223"/>
-          </a:xfrm>
-          <a:prstGeom prst="rect">
-            <a:avLst/>
-          </a:prstGeom>
-        </p:spPr>
-        <p:txBody>
-          <a:bodyPr wrap="square" lIns="0" tIns="0" rIns="0" bIns="0" rtlCol="0" anchor="t">
-            <a:spAutoFit/>
-          </a:bodyPr>
-          <a:lstStyle/>
-          <a:p>
-            <a:pPr algn="ctr">
-              <a:lnSpc>
-                <a:spcPts val="8659"/>
-              </a:lnSpc>
-            </a:pPr>
-            <a:r>
-              <a:rPr lang="en-US" sz="6185" b="1" dirty="0" err="1">
-                <a:solidFill>
-                  <a:srgbClr val="FFFFFF"/>
-                </a:solidFill>
-                <a:latin typeface="Open Sans Bold"/>
-                <a:ea typeface="Open Sans Bold"/>
-                <a:cs typeface="Open Sans Bold"/>
-                <a:sym typeface="Open Sans Bold"/>
-              </a:rPr>
-              <a:t>Quantidade</a:t>
-            </a:r>
-            <a:r>
-              <a:rPr lang="en-US" sz="6185" b="1" dirty="0">
-                <a:solidFill>
-                  <a:srgbClr val="FFFFFF"/>
-                </a:solidFill>
-                <a:latin typeface="Open Sans Bold"/>
-                <a:ea typeface="Open Sans Bold"/>
-                <a:cs typeface="Open Sans Bold"/>
-                <a:sym typeface="Open Sans Bold"/>
-              </a:rPr>
-              <a:t>: 01</a:t>
-            </a:r>
-          </a:p>
-        </p:txBody>
-      </p:sp>
-    </p:spTree>
-  </p:cSld>
-  <p:clrMapOvr>
-    <a:masterClrMapping/>
-  </p:clrMapOvr>
-</p:sld>
-</file>
-
-<file path=ppt/slides/slide18.xml><?xml version="1.0" encoding="utf-8"?>
-<p:sld xmlns:a="http://schemas.openxmlformats.org/drawingml/2006/main" xmlns:r="http://schemas.openxmlformats.org/officeDocument/2006/relationships" xmlns:p="http://schemas.openxmlformats.org/presentationml/2006/main">
-  <p:cSld>
-    <p:spTree>
-      <p:nvGrpSpPr>
-        <p:cNvPr id="1" name=""/>
-        <p:cNvGrpSpPr/>
-        <p:nvPr/>
-      </p:nvGrpSpPr>
-      <p:grpSpPr>
-        <a:xfrm>
-          <a:off x="0" y="0"/>
-          <a:ext cx="0" cy="0"/>
-          <a:chOff x="0" y="0"/>
-          <a:chExt cx="0" cy="0"/>
-        </a:xfrm>
-      </p:grpSpPr>
-      <p:sp>
-        <p:nvSpPr>
-          <p:cNvPr id="2" name="Freeform 2"/>
-          <p:cNvSpPr/>
-          <p:nvPr/>
-        </p:nvSpPr>
-        <p:spPr>
-          <a:xfrm>
-            <a:off x="0" y="0"/>
-            <a:ext cx="18288000" cy="10287000"/>
-          </a:xfrm>
-          <a:custGeom>
-            <a:avLst/>
-            <a:gdLst/>
-            <a:ahLst/>
-            <a:cxnLst/>
-            <a:rect l="l" t="t" r="r" b="b"/>
-            <a:pathLst>
-              <a:path w="18288000" h="10287000">
-                <a:moveTo>
-                  <a:pt x="0" y="0"/>
-                </a:moveTo>
-                <a:lnTo>
-                  <a:pt x="18288000" y="0"/>
-                </a:lnTo>
-                <a:lnTo>
-                  <a:pt x="18288000" y="10287000"/>
-                </a:lnTo>
-                <a:lnTo>
-                  <a:pt x="0" y="10287000"/>
-                </a:lnTo>
-                <a:lnTo>
-                  <a:pt x="0" y="0"/>
-                </a:lnTo>
-                <a:close/>
-              </a:path>
-            </a:pathLst>
-          </a:custGeom>
-          <a:blipFill>
-            <a:blip r:embed="rId2"/>
-            <a:stretch>
-              <a:fillRect/>
-            </a:stretch>
-          </a:blipFill>
-        </p:spPr>
-      </p:sp>
-      <p:sp>
-        <p:nvSpPr>
-          <p:cNvPr id="3" name="TextBox 3"/>
-          <p:cNvSpPr txBox="1"/>
-          <p:nvPr/>
-        </p:nvSpPr>
-        <p:spPr>
-          <a:xfrm>
-            <a:off x="9144000" y="7636273"/>
-            <a:ext cx="7010400" cy="1045223"/>
-          </a:xfrm>
-          <a:prstGeom prst="rect">
-            <a:avLst/>
-          </a:prstGeom>
-        </p:spPr>
-        <p:txBody>
-          <a:bodyPr wrap="square" lIns="0" tIns="0" rIns="0" bIns="0" rtlCol="0" anchor="t">
-            <a:spAutoFit/>
-          </a:bodyPr>
-          <a:lstStyle/>
-          <a:p>
-            <a:pPr algn="ctr">
-              <a:lnSpc>
-                <a:spcPts val="8659"/>
-              </a:lnSpc>
-            </a:pPr>
-            <a:r>
-              <a:rPr lang="en-US" sz="6185" b="1" dirty="0" err="1">
-                <a:solidFill>
-                  <a:srgbClr val="FFFFFF"/>
-                </a:solidFill>
-                <a:latin typeface="Open Sans Bold"/>
-                <a:ea typeface="Open Sans Bold"/>
-                <a:cs typeface="Open Sans Bold"/>
-                <a:sym typeface="Open Sans Bold"/>
-              </a:rPr>
-              <a:t>Quantidade</a:t>
-            </a:r>
-            <a:r>
-              <a:rPr lang="en-US" sz="6185" b="1" dirty="0">
-                <a:solidFill>
-                  <a:srgbClr val="FFFFFF"/>
-                </a:solidFill>
-                <a:latin typeface="Open Sans Bold"/>
-                <a:ea typeface="Open Sans Bold"/>
-                <a:cs typeface="Open Sans Bold"/>
-                <a:sym typeface="Open Sans Bold"/>
-              </a:rPr>
-              <a:t>: 01</a:t>
-            </a:r>
-          </a:p>
-        </p:txBody>
-      </p:sp>
-    </p:spTree>
-  </p:cSld>
-  <p:clrMapOvr>
-    <a:masterClrMapping/>
-  </p:clrMapOvr>
-</p:sld>
-</file>
-
-<file path=ppt/slides/slide19.xml><?xml version="1.0" encoding="utf-8"?>
-<p:sld xmlns:a="http://schemas.openxmlformats.org/drawingml/2006/main" xmlns:r="http://schemas.openxmlformats.org/officeDocument/2006/relationships" xmlns:p="http://schemas.openxmlformats.org/presentationml/2006/main">
-  <p:cSld>
-    <p:spTree>
-      <p:nvGrpSpPr>
-        <p:cNvPr id="1" name=""/>
-        <p:cNvGrpSpPr/>
-        <p:nvPr/>
-      </p:nvGrpSpPr>
-      <p:grpSpPr>
-        <a:xfrm>
-          <a:off x="0" y="0"/>
-          <a:ext cx="0" cy="0"/>
-          <a:chOff x="0" y="0"/>
-          <a:chExt cx="0" cy="0"/>
-        </a:xfrm>
-      </p:grpSpPr>
-      <p:sp>
-        <p:nvSpPr>
-          <p:cNvPr id="2" name="Freeform 2"/>
-          <p:cNvSpPr/>
-          <p:nvPr/>
-        </p:nvSpPr>
-        <p:spPr>
-          <a:xfrm>
-            <a:off x="0" y="0"/>
-            <a:ext cx="18288000" cy="10287000"/>
-          </a:xfrm>
-          <a:custGeom>
-            <a:avLst/>
-            <a:gdLst/>
-            <a:ahLst/>
-            <a:cxnLst/>
-            <a:rect l="l" t="t" r="r" b="b"/>
-            <a:pathLst>
-              <a:path w="18288000" h="10287000">
-                <a:moveTo>
-                  <a:pt x="0" y="0"/>
-                </a:moveTo>
-                <a:lnTo>
-                  <a:pt x="18288000" y="0"/>
-                </a:lnTo>
-                <a:lnTo>
-                  <a:pt x="18288000" y="10287000"/>
-                </a:lnTo>
-                <a:lnTo>
-                  <a:pt x="0" y="10287000"/>
-                </a:lnTo>
-                <a:lnTo>
-                  <a:pt x="0" y="0"/>
-                </a:lnTo>
-                <a:close/>
-              </a:path>
-            </a:pathLst>
-          </a:custGeom>
-          <a:blipFill>
-            <a:blip r:embed="rId2"/>
-            <a:stretch>
-              <a:fillRect/>
-            </a:stretch>
-          </a:blipFill>
-        </p:spPr>
-      </p:sp>
-      <p:sp>
-        <p:nvSpPr>
-          <p:cNvPr id="3" name="TextBox 3"/>
-          <p:cNvSpPr txBox="1"/>
-          <p:nvPr/>
-        </p:nvSpPr>
-        <p:spPr>
-          <a:xfrm>
-            <a:off x="7106171" y="6170086"/>
-            <a:ext cx="8286229" cy="1045223"/>
-          </a:xfrm>
-          <a:prstGeom prst="rect">
-            <a:avLst/>
-          </a:prstGeom>
-        </p:spPr>
-        <p:txBody>
-          <a:bodyPr wrap="square" lIns="0" tIns="0" rIns="0" bIns="0" rtlCol="0" anchor="t">
-            <a:spAutoFit/>
-          </a:bodyPr>
-          <a:lstStyle/>
-          <a:p>
-            <a:pPr algn="ctr">
-              <a:lnSpc>
-                <a:spcPts val="8659"/>
-              </a:lnSpc>
-            </a:pPr>
-            <a:r>
-              <a:rPr lang="en-US" sz="6185" b="1" dirty="0" err="1">
-                <a:solidFill>
-                  <a:srgbClr val="FFFFFF"/>
-                </a:solidFill>
-                <a:latin typeface="Open Sans Bold"/>
-                <a:ea typeface="Open Sans Bold"/>
-                <a:cs typeface="Open Sans Bold"/>
-                <a:sym typeface="Open Sans Bold"/>
-              </a:rPr>
-              <a:t>Quantidade</a:t>
-            </a:r>
-            <a:r>
-              <a:rPr lang="en-US" sz="6185" b="1" dirty="0">
-                <a:solidFill>
-                  <a:srgbClr val="FFFFFF"/>
-                </a:solidFill>
-                <a:latin typeface="Open Sans Bold"/>
-                <a:ea typeface="Open Sans Bold"/>
-                <a:cs typeface="Open Sans Bold"/>
-                <a:sym typeface="Open Sans Bold"/>
-              </a:rPr>
-              <a:t>: 110 kg</a:t>
-            </a:r>
-          </a:p>
-        </p:txBody>
-      </p:sp>
-      <p:sp>
-        <p:nvSpPr>
-          <p:cNvPr id="4" name="TextBox 4"/>
-          <p:cNvSpPr txBox="1"/>
-          <p:nvPr/>
-        </p:nvSpPr>
-        <p:spPr>
-          <a:xfrm>
-            <a:off x="6365299" y="8298802"/>
-            <a:ext cx="8493701" cy="1045223"/>
-          </a:xfrm>
-          <a:prstGeom prst="rect">
-            <a:avLst/>
-          </a:prstGeom>
-        </p:spPr>
-        <p:txBody>
-          <a:bodyPr wrap="square" lIns="0" tIns="0" rIns="0" bIns="0" rtlCol="0" anchor="t">
-            <a:spAutoFit/>
-          </a:bodyPr>
-          <a:lstStyle/>
-          <a:p>
-            <a:pPr algn="ctr">
-              <a:lnSpc>
-                <a:spcPts val="8659"/>
-              </a:lnSpc>
-            </a:pPr>
-            <a:r>
-              <a:rPr lang="en-US" sz="6185" b="1" dirty="0" err="1">
-                <a:solidFill>
-                  <a:srgbClr val="FFFFFF"/>
-                </a:solidFill>
-                <a:latin typeface="Open Sans Bold"/>
-                <a:ea typeface="Open Sans Bold"/>
-                <a:cs typeface="Open Sans Bold"/>
-                <a:sym typeface="Open Sans Bold"/>
-              </a:rPr>
-              <a:t>Quantidade</a:t>
-            </a:r>
-            <a:r>
-              <a:rPr lang="en-US" sz="6185" b="1" dirty="0">
-                <a:solidFill>
-                  <a:srgbClr val="FFFFFF"/>
-                </a:solidFill>
-                <a:latin typeface="Open Sans Bold"/>
-                <a:ea typeface="Open Sans Bold"/>
-                <a:cs typeface="Open Sans Bold"/>
-                <a:sym typeface="Open Sans Bold"/>
-              </a:rPr>
-              <a:t>: 100 kg</a:t>
-            </a:r>
-          </a:p>
-        </p:txBody>
-      </p:sp>
-    </p:spTree>
-  </p:cSld>
-  <p:clrMapOvr>
-    <a:masterClrMapping/>
-  </p:clrMapOvr>
-</p:sld>
-</file>
-
-<file path=ppt/slides/slide2.xml><?xml version="1.0" encoding="utf-8"?>
-<p:sld xmlns:a="http://schemas.openxmlformats.org/drawingml/2006/main" xmlns:r="http://schemas.openxmlformats.org/officeDocument/2006/relationships" xmlns:p="http://schemas.openxmlformats.org/presentationml/2006/main">
-  <p:cSld>
-    <p:spTree>
-      <p:nvGrpSpPr>
-        <p:cNvPr id="1" name=""/>
-        <p:cNvGrpSpPr/>
-        <p:nvPr/>
-      </p:nvGrpSpPr>
-      <p:grpSpPr>
-        <a:xfrm>
-          <a:off x="0" y="0"/>
-          <a:ext cx="0" cy="0"/>
-          <a:chOff x="0" y="0"/>
-          <a:chExt cx="0" cy="0"/>
-        </a:xfrm>
-      </p:grpSpPr>
-      <p:sp>
-        <p:nvSpPr>
-          <p:cNvPr id="2" name="Freeform 2"/>
-          <p:cNvSpPr/>
-          <p:nvPr/>
-        </p:nvSpPr>
-        <p:spPr>
-          <a:xfrm>
-            <a:off x="0" y="0"/>
-            <a:ext cx="18288000" cy="10287000"/>
-          </a:xfrm>
-          <a:custGeom>
-            <a:avLst/>
-            <a:gdLst/>
-            <a:ahLst/>
-            <a:cxnLst/>
-            <a:rect l="l" t="t" r="r" b="b"/>
-            <a:pathLst>
-              <a:path w="18288000" h="10287000">
-                <a:moveTo>
-                  <a:pt x="0" y="0"/>
-                </a:moveTo>
-                <a:lnTo>
-                  <a:pt x="18288000" y="0"/>
-                </a:lnTo>
-                <a:lnTo>
-                  <a:pt x="18288000" y="10287000"/>
-                </a:lnTo>
-                <a:lnTo>
-                  <a:pt x="0" y="10287000"/>
-                </a:lnTo>
-                <a:lnTo>
-                  <a:pt x="0" y="0"/>
-                </a:lnTo>
-                <a:close/>
-              </a:path>
-            </a:pathLst>
-          </a:custGeom>
-          <a:blipFill>
-            <a:blip r:embed="rId2"/>
-            <a:stretch>
-              <a:fillRect/>
-            </a:stretch>
-          </a:blipFill>
-        </p:spPr>
-      </p:sp>
     </p:spTree>
   </p:cSld>
   <p:clrMapOvr>
@@ -4795,62 +4887,58 @@
           <a:chExt cx="0" cy="0"/>
         </a:xfrm>
       </p:grpSpPr>
-      <p:sp>
-        <p:nvSpPr>
-          <p:cNvPr id="2" name="Freeform 2"/>
-          <p:cNvSpPr/>
+      <p:pic>
+        <p:nvPicPr>
+          <p:cNvPr id="6" name="Picture 5">
+            <a:extLst>
+              <a:ext uri="{FF2B5EF4-FFF2-40B4-BE49-F238E27FC236}">
+                <a16:creationId xmlns:a16="http://schemas.microsoft.com/office/drawing/2014/main" id="{6256E0AB-7366-20CF-8897-AD5F0973A032}"/>
+              </a:ext>
+            </a:extLst>
+          </p:cNvPr>
+          <p:cNvPicPr>
+            <a:picLocks noChangeAspect="1"/>
+          </p:cNvPicPr>
           <p:nvPr/>
-        </p:nvSpPr>
+        </p:nvPicPr>
+        <p:blipFill>
+          <a:blip r:embed="rId2">
+            <a:extLst>
+              <a:ext uri="{28A0092B-C50C-407E-A947-70E740481C1C}">
+                <a14:useLocalDpi xmlns:a14="http://schemas.microsoft.com/office/drawing/2010/main" val="0"/>
+              </a:ext>
+            </a:extLst>
+          </a:blip>
+          <a:stretch>
+            <a:fillRect/>
+          </a:stretch>
+        </p:blipFill>
         <p:spPr>
           <a:xfrm>
             <a:off x="0" y="0"/>
             <a:ext cx="18288000" cy="10287000"/>
           </a:xfrm>
-          <a:custGeom>
+          <a:prstGeom prst="rect">
             <a:avLst/>
-            <a:gdLst/>
-            <a:ahLst/>
-            <a:cxnLst/>
-            <a:rect l="l" t="t" r="r" b="b"/>
-            <a:pathLst>
-              <a:path w="18288000" h="10287000">
-                <a:moveTo>
-                  <a:pt x="0" y="0"/>
-                </a:moveTo>
-                <a:lnTo>
-                  <a:pt x="18288000" y="0"/>
-                </a:lnTo>
-                <a:lnTo>
-                  <a:pt x="18288000" y="10287000"/>
-                </a:lnTo>
-                <a:lnTo>
-                  <a:pt x="0" y="10287000"/>
-                </a:lnTo>
-                <a:lnTo>
-                  <a:pt x="0" y="0"/>
-                </a:lnTo>
-                <a:close/>
-              </a:path>
-            </a:pathLst>
-          </a:custGeom>
-          <a:blipFill>
-            <a:blip r:embed="rId2"/>
-            <a:stretch>
-              <a:fillRect/>
-            </a:stretch>
-          </a:blipFill>
+          </a:prstGeom>
         </p:spPr>
-      </p:sp>
-      <p:sp>
-        <p:nvSpPr>
-          <p:cNvPr id="3" name="TextBox 3"/>
+      </p:pic>
+      <p:sp>
+        <p:nvSpPr>
+          <p:cNvPr id="4" name="TextBox 3">
+            <a:extLst>
+              <a:ext uri="{FF2B5EF4-FFF2-40B4-BE49-F238E27FC236}">
+                <a16:creationId xmlns:a16="http://schemas.microsoft.com/office/drawing/2014/main" id="{5DCAF7C2-1342-DCB6-F945-0691F04B8E54}"/>
+              </a:ext>
+            </a:extLst>
+          </p:cNvPr>
           <p:cNvSpPr txBox="1"/>
           <p:nvPr/>
         </p:nvSpPr>
         <p:spPr>
           <a:xfrm>
-            <a:off x="8518318" y="6208863"/>
-            <a:ext cx="6797882" cy="1045223"/>
+            <a:off x="6858000" y="6286500"/>
+            <a:ext cx="8558315" cy="854721"/>
           </a:xfrm>
           <a:prstGeom prst="rect">
             <a:avLst/>
@@ -4862,13 +4950,13 @@
           </a:bodyPr>
           <a:lstStyle/>
           <a:p>
-            <a:pPr algn="ctr">
+            <a:pPr>
               <a:lnSpc>
-                <a:spcPts val="8659"/>
+                <a:spcPts val="7212"/>
               </a:lnSpc>
             </a:pPr>
             <a:r>
-              <a:rPr lang="en-US" sz="6185" b="1" dirty="0" err="1">
+              <a:rPr lang="en-US" sz="4900" b="1" dirty="0" err="1">
                 <a:solidFill>
                   <a:srgbClr val="FFFFFF"/>
                 </a:solidFill>
@@ -4880,7 +4968,7 @@
               <a:t>Quantidade</a:t>
             </a:r>
             <a:r>
-              <a:rPr lang="en-US" sz="6185" b="1" dirty="0">
+              <a:rPr lang="en-US" sz="4900" b="1" dirty="0">
                 <a:solidFill>
                   <a:srgbClr val="FFFFFF"/>
                 </a:solidFill>
@@ -4889,21 +4977,27 @@
                 <a:cs typeface="Open Sans Bold"/>
                 <a:sym typeface="Open Sans Bold"/>
               </a:rPr>
-              <a:t>: 01</a:t>
+              <a:t>: [PUX_RETO]</a:t>
             </a:r>
           </a:p>
         </p:txBody>
       </p:sp>
       <p:sp>
         <p:nvSpPr>
-          <p:cNvPr id="4" name="TextBox 4"/>
+          <p:cNvPr id="5" name="TextBox 4">
+            <a:extLst>
+              <a:ext uri="{FF2B5EF4-FFF2-40B4-BE49-F238E27FC236}">
+                <a16:creationId xmlns:a16="http://schemas.microsoft.com/office/drawing/2014/main" id="{0EC2E8AA-6B08-2D04-F78D-AC9E6043ED3D}"/>
+              </a:ext>
+            </a:extLst>
+          </p:cNvPr>
           <p:cNvSpPr txBox="1"/>
           <p:nvPr/>
         </p:nvSpPr>
         <p:spPr>
           <a:xfrm>
-            <a:off x="8518318" y="8298802"/>
-            <a:ext cx="7026482" cy="1045223"/>
+            <a:off x="7467600" y="8251179"/>
+            <a:ext cx="8558315" cy="854721"/>
           </a:xfrm>
           <a:prstGeom prst="rect">
             <a:avLst/>
@@ -4915,13 +5009,13 @@
           </a:bodyPr>
           <a:lstStyle/>
           <a:p>
-            <a:pPr algn="ctr">
+            <a:pPr>
               <a:lnSpc>
-                <a:spcPts val="8659"/>
+                <a:spcPts val="7212"/>
               </a:lnSpc>
             </a:pPr>
             <a:r>
-              <a:rPr lang="en-US" sz="6185" b="1" dirty="0" err="1">
+              <a:rPr lang="en-US" sz="4900" b="1" dirty="0" err="1">
                 <a:solidFill>
                   <a:srgbClr val="FFFFFF"/>
                 </a:solidFill>
@@ -4933,7 +5027,7 @@
               <a:t>Quantidade</a:t>
             </a:r>
             <a:r>
-              <a:rPr lang="en-US" sz="6185" b="1" dirty="0">
+              <a:rPr lang="en-US" sz="4900" b="1" dirty="0">
                 <a:solidFill>
                   <a:srgbClr val="FFFFFF"/>
                 </a:solidFill>
@@ -4942,12 +5036,17 @@
                 <a:cs typeface="Open Sans Bold"/>
                 <a:sym typeface="Open Sans Bold"/>
               </a:rPr>
-              <a:t>: 01</a:t>
+              <a:t>: [PUX_TORNO]</a:t>
             </a:r>
           </a:p>
         </p:txBody>
       </p:sp>
     </p:spTree>
+    <p:extLst>
+      <p:ext uri="{BB962C8B-B14F-4D97-AF65-F5344CB8AC3E}">
+        <p14:creationId xmlns:p14="http://schemas.microsoft.com/office/powerpoint/2010/main" val="2605821849"/>
+      </p:ext>
+    </p:extLst>
   </p:cSld>
   <p:clrMapOvr>
     <a:masterClrMapping/>
@@ -4972,282 +5071,42 @@
           <a:chExt cx="0" cy="0"/>
         </a:xfrm>
       </p:grpSpPr>
-      <p:sp>
-        <p:nvSpPr>
-          <p:cNvPr id="2" name="Freeform 2"/>
-          <p:cNvSpPr/>
+      <p:pic>
+        <p:nvPicPr>
+          <p:cNvPr id="6" name="Picture 5">
+            <a:extLst>
+              <a:ext uri="{FF2B5EF4-FFF2-40B4-BE49-F238E27FC236}">
+                <a16:creationId xmlns:a16="http://schemas.microsoft.com/office/drawing/2014/main" id="{6FCF21C4-18A6-5DF9-7FCF-28D5EF100400}"/>
+              </a:ext>
+            </a:extLst>
+          </p:cNvPr>
+          <p:cNvPicPr>
+            <a:picLocks noChangeAspect="1"/>
+          </p:cNvPicPr>
           <p:nvPr/>
-        </p:nvSpPr>
+        </p:nvPicPr>
+        <p:blipFill>
+          <a:blip r:embed="rId2">
+            <a:extLst>
+              <a:ext uri="{28A0092B-C50C-407E-A947-70E740481C1C}">
+                <a14:useLocalDpi xmlns:a14="http://schemas.microsoft.com/office/drawing/2010/main" val="0"/>
+              </a:ext>
+            </a:extLst>
+          </a:blip>
+          <a:stretch>
+            <a:fillRect/>
+          </a:stretch>
+        </p:blipFill>
         <p:spPr>
           <a:xfrm>
             <a:off x="0" y="0"/>
             <a:ext cx="18288000" cy="10287000"/>
           </a:xfrm>
-          <a:custGeom>
-            <a:avLst/>
-            <a:gdLst/>
-            <a:ahLst/>
-            <a:cxnLst/>
-            <a:rect l="l" t="t" r="r" b="b"/>
-            <a:pathLst>
-              <a:path w="18288000" h="10287000">
-                <a:moveTo>
-                  <a:pt x="0" y="0"/>
-                </a:moveTo>
-                <a:lnTo>
-                  <a:pt x="18288000" y="0"/>
-                </a:lnTo>
-                <a:lnTo>
-                  <a:pt x="18288000" y="10287000"/>
-                </a:lnTo>
-                <a:lnTo>
-                  <a:pt x="0" y="10287000"/>
-                </a:lnTo>
-                <a:lnTo>
-                  <a:pt x="0" y="0"/>
-                </a:lnTo>
-                <a:close/>
-              </a:path>
-            </a:pathLst>
-          </a:custGeom>
-          <a:blipFill>
-            <a:blip r:embed="rId2"/>
-            <a:stretch>
-              <a:fillRect/>
-            </a:stretch>
-          </a:blipFill>
-        </p:spPr>
-      </p:sp>
-      <p:sp>
-        <p:nvSpPr>
-          <p:cNvPr id="3" name="TextBox 3"/>
-          <p:cNvSpPr txBox="1"/>
-          <p:nvPr/>
-        </p:nvSpPr>
-        <p:spPr>
-          <a:xfrm>
-            <a:off x="5532999" y="5341070"/>
-            <a:ext cx="4972767" cy="878521"/>
-          </a:xfrm>
           <a:prstGeom prst="rect">
             <a:avLst/>
           </a:prstGeom>
         </p:spPr>
-        <p:txBody>
-          <a:bodyPr lIns="0" tIns="0" rIns="0" bIns="0" rtlCol="0" anchor="t">
-            <a:spAutoFit/>
-          </a:bodyPr>
-          <a:lstStyle/>
-          <a:p>
-            <a:pPr algn="ctr">
-              <a:lnSpc>
-                <a:spcPts val="7212"/>
-              </a:lnSpc>
-            </a:pPr>
-            <a:r>
-              <a:rPr lang="en-US" sz="4900" b="1" dirty="0" err="1">
-                <a:solidFill>
-                  <a:srgbClr val="FFFFFF"/>
-                </a:solidFill>
-                <a:latin typeface="Open Sans Bold"/>
-                <a:ea typeface="Open Sans Bold"/>
-                <a:cs typeface="Open Sans Bold"/>
-                <a:sym typeface="Open Sans Bold"/>
-              </a:rPr>
-              <a:t>Quantidade</a:t>
-            </a:r>
-            <a:r>
-              <a:rPr lang="en-US" sz="4900" b="1" dirty="0">
-                <a:solidFill>
-                  <a:srgbClr val="FFFFFF"/>
-                </a:solidFill>
-                <a:latin typeface="Open Sans Bold"/>
-                <a:ea typeface="Open Sans Bold"/>
-                <a:cs typeface="Open Sans Bold"/>
-                <a:sym typeface="Open Sans Bold"/>
-              </a:rPr>
-              <a:t>: 01</a:t>
-            </a:r>
-          </a:p>
-        </p:txBody>
-      </p:sp>
-      <p:sp>
-        <p:nvSpPr>
-          <p:cNvPr id="4" name="TextBox 4"/>
-          <p:cNvSpPr txBox="1"/>
-          <p:nvPr/>
-        </p:nvSpPr>
-        <p:spPr>
-          <a:xfrm>
-            <a:off x="6342624" y="7222257"/>
-            <a:ext cx="4972767" cy="878521"/>
-          </a:xfrm>
-          <a:prstGeom prst="rect">
-            <a:avLst/>
-          </a:prstGeom>
-        </p:spPr>
-        <p:txBody>
-          <a:bodyPr lIns="0" tIns="0" rIns="0" bIns="0" rtlCol="0" anchor="t">
-            <a:spAutoFit/>
-          </a:bodyPr>
-          <a:lstStyle/>
-          <a:p>
-            <a:pPr algn="ctr">
-              <a:lnSpc>
-                <a:spcPts val="7212"/>
-              </a:lnSpc>
-            </a:pPr>
-            <a:r>
-              <a:rPr lang="en-US" sz="4900" b="1" dirty="0" err="1">
-                <a:solidFill>
-                  <a:srgbClr val="FFFFFF"/>
-                </a:solidFill>
-                <a:latin typeface="Open Sans Bold"/>
-                <a:ea typeface="Open Sans Bold"/>
-                <a:cs typeface="Open Sans Bold"/>
-                <a:sym typeface="Open Sans Bold"/>
-              </a:rPr>
-              <a:t>Quantidade</a:t>
-            </a:r>
-            <a:r>
-              <a:rPr lang="en-US" sz="4900" b="1" dirty="0">
-                <a:solidFill>
-                  <a:srgbClr val="FFFFFF"/>
-                </a:solidFill>
-                <a:latin typeface="Open Sans Bold"/>
-                <a:ea typeface="Open Sans Bold"/>
-                <a:cs typeface="Open Sans Bold"/>
-                <a:sym typeface="Open Sans Bold"/>
-              </a:rPr>
-              <a:t>: 01</a:t>
-            </a:r>
-          </a:p>
-        </p:txBody>
-      </p:sp>
-      <p:sp>
-        <p:nvSpPr>
-          <p:cNvPr id="5" name="TextBox 5"/>
-          <p:cNvSpPr txBox="1"/>
-          <p:nvPr/>
-        </p:nvSpPr>
-        <p:spPr>
-          <a:xfrm>
-            <a:off x="7223686" y="8958028"/>
-            <a:ext cx="4972767" cy="878521"/>
-          </a:xfrm>
-          <a:prstGeom prst="rect">
-            <a:avLst/>
-          </a:prstGeom>
-        </p:spPr>
-        <p:txBody>
-          <a:bodyPr lIns="0" tIns="0" rIns="0" bIns="0" rtlCol="0" anchor="t">
-            <a:spAutoFit/>
-          </a:bodyPr>
-          <a:lstStyle/>
-          <a:p>
-            <a:pPr algn="ctr">
-              <a:lnSpc>
-                <a:spcPts val="7212"/>
-              </a:lnSpc>
-            </a:pPr>
-            <a:r>
-              <a:rPr lang="en-US" sz="4900" b="1" dirty="0" err="1">
-                <a:solidFill>
-                  <a:srgbClr val="FFFFFF"/>
-                </a:solidFill>
-                <a:latin typeface="Open Sans Bold"/>
-                <a:ea typeface="Open Sans Bold"/>
-                <a:cs typeface="Open Sans Bold"/>
-                <a:sym typeface="Open Sans Bold"/>
-              </a:rPr>
-              <a:t>Quantidade</a:t>
-            </a:r>
-            <a:r>
-              <a:rPr lang="en-US" sz="4900" b="1" dirty="0">
-                <a:solidFill>
-                  <a:srgbClr val="FFFFFF"/>
-                </a:solidFill>
-                <a:latin typeface="Open Sans Bold"/>
-                <a:ea typeface="Open Sans Bold"/>
-                <a:cs typeface="Open Sans Bold"/>
-                <a:sym typeface="Open Sans Bold"/>
-              </a:rPr>
-              <a:t>: 01</a:t>
-            </a:r>
-          </a:p>
-        </p:txBody>
-      </p:sp>
-    </p:spTree>
-  </p:cSld>
-  <p:clrMapOvr>
-    <a:masterClrMapping/>
-  </p:clrMapOvr>
-</p:sld>
-</file>
-
-<file path=ppt/slides/slide22.xml><?xml version="1.0" encoding="utf-8"?>
-<p:sld xmlns:a="http://schemas.openxmlformats.org/drawingml/2006/main" xmlns:r="http://schemas.openxmlformats.org/officeDocument/2006/relationships" xmlns:p="http://schemas.openxmlformats.org/presentationml/2006/main">
-  <p:cSld>
-    <p:spTree>
-      <p:nvGrpSpPr>
-        <p:cNvPr id="1" name=""/>
-        <p:cNvGrpSpPr/>
-        <p:nvPr/>
-      </p:nvGrpSpPr>
-      <p:grpSpPr>
-        <a:xfrm>
-          <a:off x="0" y="0"/>
-          <a:ext cx="0" cy="0"/>
-          <a:chOff x="0" y="0"/>
-          <a:chExt cx="0" cy="0"/>
-        </a:xfrm>
-      </p:grpSpPr>
-      <p:sp>
-        <p:nvSpPr>
-          <p:cNvPr id="2" name="Freeform 2"/>
-          <p:cNvSpPr/>
-          <p:nvPr/>
-        </p:nvSpPr>
-        <p:spPr>
-          <a:xfrm>
-            <a:off x="0" y="0"/>
-            <a:ext cx="18288000" cy="10287000"/>
-          </a:xfrm>
-          <a:custGeom>
-            <a:avLst/>
-            <a:gdLst/>
-            <a:ahLst/>
-            <a:cxnLst/>
-            <a:rect l="l" t="t" r="r" b="b"/>
-            <a:pathLst>
-              <a:path w="18288000" h="10287000">
-                <a:moveTo>
-                  <a:pt x="0" y="0"/>
-                </a:moveTo>
-                <a:lnTo>
-                  <a:pt x="18288000" y="0"/>
-                </a:lnTo>
-                <a:lnTo>
-                  <a:pt x="18288000" y="10287000"/>
-                </a:lnTo>
-                <a:lnTo>
-                  <a:pt x="0" y="10287000"/>
-                </a:lnTo>
-                <a:lnTo>
-                  <a:pt x="0" y="0"/>
-                </a:lnTo>
-                <a:close/>
-              </a:path>
-            </a:pathLst>
-          </a:custGeom>
-          <a:blipFill>
-            <a:blip r:embed="rId2"/>
-            <a:stretch>
-              <a:fillRect/>
-            </a:stretch>
-          </a:blipFill>
-        </p:spPr>
-      </p:sp>
+      </p:pic>
       <p:sp>
         <p:nvSpPr>
           <p:cNvPr id="3" name="TextBox 3"/>
@@ -5256,415 +5115,8 @@
         </p:nvSpPr>
         <p:spPr>
           <a:xfrm>
-            <a:off x="7519885" y="5270903"/>
-            <a:ext cx="4972767" cy="878521"/>
-          </a:xfrm>
-          <a:prstGeom prst="rect">
-            <a:avLst/>
-          </a:prstGeom>
-        </p:spPr>
-        <p:txBody>
-          <a:bodyPr lIns="0" tIns="0" rIns="0" bIns="0" rtlCol="0" anchor="t">
-            <a:spAutoFit/>
-          </a:bodyPr>
-          <a:lstStyle/>
-          <a:p>
-            <a:pPr algn="ctr">
-              <a:lnSpc>
-                <a:spcPts val="7212"/>
-              </a:lnSpc>
-            </a:pPr>
-            <a:r>
-              <a:rPr lang="en-US" sz="4900" b="1" dirty="0" err="1">
-                <a:solidFill>
-                  <a:srgbClr val="FFFFFF"/>
-                </a:solidFill>
-                <a:latin typeface="Open Sans Bold"/>
-                <a:ea typeface="Open Sans Bold"/>
-                <a:cs typeface="Open Sans Bold"/>
-                <a:sym typeface="Open Sans Bold"/>
-              </a:rPr>
-              <a:t>Quantidade</a:t>
-            </a:r>
-            <a:r>
-              <a:rPr lang="en-US" sz="4900" b="1" dirty="0">
-                <a:solidFill>
-                  <a:srgbClr val="FFFFFF"/>
-                </a:solidFill>
-                <a:latin typeface="Open Sans Bold"/>
-                <a:ea typeface="Open Sans Bold"/>
-                <a:cs typeface="Open Sans Bold"/>
-                <a:sym typeface="Open Sans Bold"/>
-              </a:rPr>
-              <a:t>: 01</a:t>
-            </a:r>
-          </a:p>
-        </p:txBody>
-      </p:sp>
-      <p:sp>
-        <p:nvSpPr>
-          <p:cNvPr id="4" name="TextBox 4"/>
-          <p:cNvSpPr txBox="1"/>
-          <p:nvPr/>
-        </p:nvSpPr>
-        <p:spPr>
-          <a:xfrm>
-            <a:off x="8329510" y="7130499"/>
-            <a:ext cx="4972767" cy="878521"/>
-          </a:xfrm>
-          <a:prstGeom prst="rect">
-            <a:avLst/>
-          </a:prstGeom>
-        </p:spPr>
-        <p:txBody>
-          <a:bodyPr lIns="0" tIns="0" rIns="0" bIns="0" rtlCol="0" anchor="t">
-            <a:spAutoFit/>
-          </a:bodyPr>
-          <a:lstStyle/>
-          <a:p>
-            <a:pPr algn="ctr">
-              <a:lnSpc>
-                <a:spcPts val="7212"/>
-              </a:lnSpc>
-            </a:pPr>
-            <a:r>
-              <a:rPr lang="en-US" sz="4900" b="1" dirty="0" err="1">
-                <a:solidFill>
-                  <a:srgbClr val="FFFFFF"/>
-                </a:solidFill>
-                <a:latin typeface="Open Sans Bold"/>
-                <a:ea typeface="Open Sans Bold"/>
-                <a:cs typeface="Open Sans Bold"/>
-                <a:sym typeface="Open Sans Bold"/>
-              </a:rPr>
-              <a:t>Quantidade</a:t>
-            </a:r>
-            <a:r>
-              <a:rPr lang="en-US" sz="4900" b="1" dirty="0">
-                <a:solidFill>
-                  <a:srgbClr val="FFFFFF"/>
-                </a:solidFill>
-                <a:latin typeface="Open Sans Bold"/>
-                <a:ea typeface="Open Sans Bold"/>
-                <a:cs typeface="Open Sans Bold"/>
-                <a:sym typeface="Open Sans Bold"/>
-              </a:rPr>
-              <a:t>: 01</a:t>
-            </a:r>
-          </a:p>
-        </p:txBody>
-      </p:sp>
-      <p:sp>
-        <p:nvSpPr>
-          <p:cNvPr id="5" name="TextBox 5"/>
-          <p:cNvSpPr txBox="1"/>
-          <p:nvPr/>
-        </p:nvSpPr>
-        <p:spPr>
-          <a:xfrm>
-            <a:off x="9210572" y="8938978"/>
-            <a:ext cx="4972767" cy="878521"/>
-          </a:xfrm>
-          <a:prstGeom prst="rect">
-            <a:avLst/>
-          </a:prstGeom>
-        </p:spPr>
-        <p:txBody>
-          <a:bodyPr lIns="0" tIns="0" rIns="0" bIns="0" rtlCol="0" anchor="t">
-            <a:spAutoFit/>
-          </a:bodyPr>
-          <a:lstStyle/>
-          <a:p>
-            <a:pPr algn="ctr">
-              <a:lnSpc>
-                <a:spcPts val="7212"/>
-              </a:lnSpc>
-            </a:pPr>
-            <a:r>
-              <a:rPr lang="en-US" sz="4900" b="1" dirty="0" err="1">
-                <a:solidFill>
-                  <a:srgbClr val="FFFFFF"/>
-                </a:solidFill>
-                <a:latin typeface="Open Sans Bold"/>
-                <a:ea typeface="Open Sans Bold"/>
-                <a:cs typeface="Open Sans Bold"/>
-                <a:sym typeface="Open Sans Bold"/>
-              </a:rPr>
-              <a:t>Quantidade</a:t>
-            </a:r>
-            <a:r>
-              <a:rPr lang="en-US" sz="4900" b="1" dirty="0">
-                <a:solidFill>
-                  <a:srgbClr val="FFFFFF"/>
-                </a:solidFill>
-                <a:latin typeface="Open Sans Bold"/>
-                <a:ea typeface="Open Sans Bold"/>
-                <a:cs typeface="Open Sans Bold"/>
-                <a:sym typeface="Open Sans Bold"/>
-              </a:rPr>
-              <a:t>: 02</a:t>
-            </a:r>
-          </a:p>
-        </p:txBody>
-      </p:sp>
-    </p:spTree>
-  </p:cSld>
-  <p:clrMapOvr>
-    <a:masterClrMapping/>
-  </p:clrMapOvr>
-</p:sld>
-</file>
-
-<file path=ppt/slides/slide23.xml><?xml version="1.0" encoding="utf-8"?>
-<p:sld xmlns:a="http://schemas.openxmlformats.org/drawingml/2006/main" xmlns:r="http://schemas.openxmlformats.org/officeDocument/2006/relationships" xmlns:p="http://schemas.openxmlformats.org/presentationml/2006/main">
-  <p:cSld>
-    <p:spTree>
-      <p:nvGrpSpPr>
-        <p:cNvPr id="1" name=""/>
-        <p:cNvGrpSpPr/>
-        <p:nvPr/>
-      </p:nvGrpSpPr>
-      <p:grpSpPr>
-        <a:xfrm>
-          <a:off x="0" y="0"/>
-          <a:ext cx="0" cy="0"/>
-          <a:chOff x="0" y="0"/>
-          <a:chExt cx="0" cy="0"/>
-        </a:xfrm>
-      </p:grpSpPr>
-      <p:sp>
-        <p:nvSpPr>
-          <p:cNvPr id="2" name="Freeform 2"/>
-          <p:cNvSpPr/>
-          <p:nvPr/>
-        </p:nvSpPr>
-        <p:spPr>
-          <a:xfrm>
-            <a:off x="0" y="0"/>
-            <a:ext cx="18288000" cy="10287000"/>
-          </a:xfrm>
-          <a:custGeom>
-            <a:avLst/>
-            <a:gdLst/>
-            <a:ahLst/>
-            <a:cxnLst/>
-            <a:rect l="l" t="t" r="r" b="b"/>
-            <a:pathLst>
-              <a:path w="18288000" h="10287000">
-                <a:moveTo>
-                  <a:pt x="0" y="0"/>
-                </a:moveTo>
-                <a:lnTo>
-                  <a:pt x="18288000" y="0"/>
-                </a:lnTo>
-                <a:lnTo>
-                  <a:pt x="18288000" y="10287000"/>
-                </a:lnTo>
-                <a:lnTo>
-                  <a:pt x="0" y="10287000"/>
-                </a:lnTo>
-                <a:lnTo>
-                  <a:pt x="0" y="0"/>
-                </a:lnTo>
-                <a:close/>
-              </a:path>
-            </a:pathLst>
-          </a:custGeom>
-          <a:blipFill>
-            <a:blip r:embed="rId2"/>
-            <a:stretch>
-              <a:fillRect/>
-            </a:stretch>
-          </a:blipFill>
-        </p:spPr>
-      </p:sp>
-      <p:sp>
-        <p:nvSpPr>
-          <p:cNvPr id="3" name="TextBox 3"/>
-          <p:cNvSpPr txBox="1"/>
-          <p:nvPr/>
-        </p:nvSpPr>
-        <p:spPr>
-          <a:xfrm>
-            <a:off x="6543317" y="6290043"/>
-            <a:ext cx="4972767" cy="878521"/>
-          </a:xfrm>
-          <a:prstGeom prst="rect">
-            <a:avLst/>
-          </a:prstGeom>
-        </p:spPr>
-        <p:txBody>
-          <a:bodyPr lIns="0" tIns="0" rIns="0" bIns="0" rtlCol="0" anchor="t">
-            <a:spAutoFit/>
-          </a:bodyPr>
-          <a:lstStyle/>
-          <a:p>
-            <a:pPr algn="ctr">
-              <a:lnSpc>
-                <a:spcPts val="7212"/>
-              </a:lnSpc>
-            </a:pPr>
-            <a:r>
-              <a:rPr lang="en-US" sz="4900" b="1" dirty="0" err="1">
-                <a:solidFill>
-                  <a:srgbClr val="FFFFFF"/>
-                </a:solidFill>
-                <a:latin typeface="Open Sans Bold"/>
-                <a:ea typeface="Open Sans Bold"/>
-                <a:cs typeface="Open Sans Bold"/>
-                <a:sym typeface="Open Sans Bold"/>
-              </a:rPr>
-              <a:t>Quantidade</a:t>
-            </a:r>
-            <a:r>
-              <a:rPr lang="en-US" sz="4900" b="1" dirty="0">
-                <a:solidFill>
-                  <a:srgbClr val="FFFFFF"/>
-                </a:solidFill>
-                <a:latin typeface="Open Sans Bold"/>
-                <a:ea typeface="Open Sans Bold"/>
-                <a:cs typeface="Open Sans Bold"/>
-                <a:sym typeface="Open Sans Bold"/>
-              </a:rPr>
-              <a:t>: 02</a:t>
-            </a:r>
-          </a:p>
-        </p:txBody>
-      </p:sp>
-      <p:sp>
-        <p:nvSpPr>
-          <p:cNvPr id="4" name="TextBox 4"/>
-          <p:cNvSpPr txBox="1"/>
-          <p:nvPr/>
-        </p:nvSpPr>
-        <p:spPr>
-          <a:xfrm>
-            <a:off x="7105292" y="8379779"/>
-            <a:ext cx="4972767" cy="878521"/>
-          </a:xfrm>
-          <a:prstGeom prst="rect">
-            <a:avLst/>
-          </a:prstGeom>
-        </p:spPr>
-        <p:txBody>
-          <a:bodyPr lIns="0" tIns="0" rIns="0" bIns="0" rtlCol="0" anchor="t">
-            <a:spAutoFit/>
-          </a:bodyPr>
-          <a:lstStyle/>
-          <a:p>
-            <a:pPr algn="ctr">
-              <a:lnSpc>
-                <a:spcPts val="7212"/>
-              </a:lnSpc>
-            </a:pPr>
-            <a:r>
-              <a:rPr lang="en-US" sz="4900" b="1" dirty="0" err="1">
-                <a:solidFill>
-                  <a:srgbClr val="FFFFFF"/>
-                </a:solidFill>
-                <a:latin typeface="Open Sans Bold"/>
-                <a:ea typeface="Open Sans Bold"/>
-                <a:cs typeface="Open Sans Bold"/>
-                <a:sym typeface="Open Sans Bold"/>
-              </a:rPr>
-              <a:t>Quantidade</a:t>
-            </a:r>
-            <a:r>
-              <a:rPr lang="en-US" sz="4900" b="1" dirty="0">
-                <a:solidFill>
-                  <a:srgbClr val="FFFFFF"/>
-                </a:solidFill>
-                <a:latin typeface="Open Sans Bold"/>
-                <a:ea typeface="Open Sans Bold"/>
-                <a:cs typeface="Open Sans Bold"/>
-                <a:sym typeface="Open Sans Bold"/>
-              </a:rPr>
-              <a:t>: 01</a:t>
-            </a:r>
-          </a:p>
-        </p:txBody>
-      </p:sp>
-    </p:spTree>
-  </p:cSld>
-  <p:clrMapOvr>
-    <a:masterClrMapping/>
-  </p:clrMapOvr>
-</p:sld>
-</file>
-
-<file path=ppt/slides/slide24.xml><?xml version="1.0" encoding="utf-8"?>
-<p:sld xmlns:a="http://schemas.openxmlformats.org/drawingml/2006/main" xmlns:r="http://schemas.openxmlformats.org/officeDocument/2006/relationships" xmlns:p="http://schemas.openxmlformats.org/presentationml/2006/main">
-  <p:cSld>
-    <p:spTree>
-      <p:nvGrpSpPr>
-        <p:cNvPr id="1" name=""/>
-        <p:cNvGrpSpPr/>
-        <p:nvPr/>
-      </p:nvGrpSpPr>
-      <p:grpSpPr>
-        <a:xfrm>
-          <a:off x="0" y="0"/>
-          <a:ext cx="0" cy="0"/>
-          <a:chOff x="0" y="0"/>
-          <a:chExt cx="0" cy="0"/>
-        </a:xfrm>
-      </p:grpSpPr>
-      <p:sp>
-        <p:nvSpPr>
-          <p:cNvPr id="2" name="Freeform 2"/>
-          <p:cNvSpPr/>
-          <p:nvPr/>
-        </p:nvSpPr>
-        <p:spPr>
-          <a:xfrm>
-            <a:off x="0" y="0"/>
-            <a:ext cx="18288000" cy="10287000"/>
-          </a:xfrm>
-          <a:custGeom>
-            <a:avLst/>
-            <a:gdLst/>
-            <a:ahLst/>
-            <a:cxnLst/>
-            <a:rect l="l" t="t" r="r" b="b"/>
-            <a:pathLst>
-              <a:path w="18288000" h="10287000">
-                <a:moveTo>
-                  <a:pt x="0" y="0"/>
-                </a:moveTo>
-                <a:lnTo>
-                  <a:pt x="18288000" y="0"/>
-                </a:lnTo>
-                <a:lnTo>
-                  <a:pt x="18288000" y="10287000"/>
-                </a:lnTo>
-                <a:lnTo>
-                  <a:pt x="0" y="10287000"/>
-                </a:lnTo>
-                <a:lnTo>
-                  <a:pt x="0" y="0"/>
-                </a:lnTo>
-                <a:close/>
-              </a:path>
-            </a:pathLst>
-          </a:custGeom>
-          <a:blipFill>
-            <a:blip r:embed="rId2"/>
-            <a:stretch>
-              <a:fillRect/>
-            </a:stretch>
-          </a:blipFill>
-        </p:spPr>
-      </p:sp>
-      <p:sp>
-        <p:nvSpPr>
-          <p:cNvPr id="3" name="TextBox 3"/>
-          <p:cNvSpPr txBox="1"/>
-          <p:nvPr/>
-        </p:nvSpPr>
-        <p:spPr>
-          <a:xfrm>
-            <a:off x="7171277" y="8213077"/>
-            <a:ext cx="6925723" cy="1045223"/>
+            <a:off x="8686800" y="8222919"/>
+            <a:ext cx="10210800" cy="1041504"/>
           </a:xfrm>
           <a:prstGeom prst="rect">
             <a:avLst/>
@@ -5676,7 +5128,7 @@
           </a:bodyPr>
           <a:lstStyle/>
           <a:p>
-            <a:pPr algn="ctr">
+            <a:pPr>
               <a:lnSpc>
                 <a:spcPts val="8659"/>
               </a:lnSpc>
@@ -5703,7 +5155,7 @@
                 <a:cs typeface="Open Sans Bold"/>
                 <a:sym typeface="Open Sans Bold"/>
               </a:rPr>
-              <a:t>: 02</a:t>
+              <a:t>: [STEP_LIGHT]</a:t>
             </a:r>
           </a:p>
         </p:txBody>
@@ -5716,8 +5168,8 @@
         </p:nvSpPr>
         <p:spPr>
           <a:xfrm>
-            <a:off x="6901869" y="6158839"/>
-            <a:ext cx="6661731" cy="1045223"/>
+            <a:off x="7315200" y="6158838"/>
+            <a:ext cx="11582400" cy="1041504"/>
           </a:xfrm>
           <a:prstGeom prst="rect">
             <a:avLst/>
@@ -5729,7 +5181,7 @@
           </a:bodyPr>
           <a:lstStyle/>
           <a:p>
-            <a:pPr algn="ctr">
+            <a:pPr>
               <a:lnSpc>
                 <a:spcPts val="8659"/>
               </a:lnSpc>
@@ -5756,7 +5208,7 @@
                 <a:cs typeface="Open Sans Bold"/>
                 <a:sym typeface="Open Sans Bold"/>
               </a:rPr>
-              <a:t>: 02</a:t>
+              <a:t>: [COLCHONETE]</a:t>
             </a:r>
           </a:p>
         </p:txBody>
@@ -5769,7 +5221,7 @@
 </p:sld>
 </file>
 
-<file path=ppt/slides/slide25.xml><?xml version="1.0" encoding="utf-8"?>
+<file path=ppt/slides/slide22.xml><?xml version="1.0" encoding="utf-8"?>
 <p:sld xmlns:a="http://schemas.openxmlformats.org/drawingml/2006/main" xmlns:r="http://schemas.openxmlformats.org/officeDocument/2006/relationships" xmlns:p="http://schemas.openxmlformats.org/presentationml/2006/main">
   <p:cSld>
     <p:spTree>
@@ -8255,7 +7707,7 @@
 </p:sld>
 </file>
 
-<file path=ppt/slides/slide26.xml><?xml version="1.0" encoding="utf-8"?>
+<file path=ppt/slides/slide23.xml><?xml version="1.0" encoding="utf-8"?>
 <p:sld xmlns:a="http://schemas.openxmlformats.org/drawingml/2006/main" xmlns:r="http://schemas.openxmlformats.org/officeDocument/2006/relationships" xmlns:p="http://schemas.openxmlformats.org/presentationml/2006/main">
   <p:cSld>
     <p:spTree>
@@ -9650,7 +9102,7 @@
 </p:sld>
 </file>
 
-<file path=ppt/slides/slide27.xml><?xml version="1.0" encoding="utf-8"?>
+<file path=ppt/slides/slide24.xml><?xml version="1.0" encoding="utf-8"?>
 <p:sld xmlns:a="http://schemas.openxmlformats.org/drawingml/2006/main" xmlns:r="http://schemas.openxmlformats.org/officeDocument/2006/relationships" xmlns:p="http://schemas.openxmlformats.org/presentationml/2006/main">
   <p:cSld>
     <p:spTree>

</xml_diff>

<commit_message>
Adicionar função de adicionar equipamentos diferentes
</commit_message>
<xml_diff>
--- a/simulador_duofitness/templates/uno.pptx
+++ b/simulador_duofitness/templates/uno.pptx
@@ -34,14 +34,10 @@
   <p:notesSz cx="6858000" cy="9144000"/>
   <p:embeddedFontLst>
     <p:embeddedFont>
-      <p:font typeface="Open Sans" pitchFamily="2" charset="0"/>
+      <p:font typeface="Open Sans" panose="020B0806030504020204" pitchFamily="34" charset="0"/>
       <p:regular r:id="rId26"/>
       <p:bold r:id="rId27"/>
       <p:boldItalic r:id="rId28"/>
-    </p:embeddedFont>
-    <p:embeddedFont>
-      <p:font typeface="Open Sans Bold" pitchFamily="2" charset="0"/>
-      <p:bold r:id="rId29"/>
     </p:embeddedFont>
   </p:embeddedFontLst>
   <p:defaultTextStyle>
@@ -338,7 +334,7 @@
             <a:fld id="{1D8BD707-D9CF-40AE-B4C6-C98DA3205C09}" type="datetimeFigureOut">
               <a:rPr lang="en-US" smtClean="0"/>
               <a:pPr/>
-              <a:t>6/30/2026</a:t>
+              <a:t>7/10/2026</a:t>
             </a:fld>
             <a:endParaRPr lang="en-US"/>
           </a:p>
@@ -503,7 +499,7 @@
             <a:fld id="{1D8BD707-D9CF-40AE-B4C6-C98DA3205C09}" type="datetimeFigureOut">
               <a:rPr lang="en-US" smtClean="0"/>
               <a:pPr/>
-              <a:t>6/30/2026</a:t>
+              <a:t>7/10/2026</a:t>
             </a:fld>
             <a:endParaRPr lang="en-US"/>
           </a:p>
@@ -678,7 +674,7 @@
             <a:fld id="{1D8BD707-D9CF-40AE-B4C6-C98DA3205C09}" type="datetimeFigureOut">
               <a:rPr lang="en-US" smtClean="0"/>
               <a:pPr/>
-              <a:t>6/30/2026</a:t>
+              <a:t>7/10/2026</a:t>
             </a:fld>
             <a:endParaRPr lang="en-US"/>
           </a:p>
@@ -843,7 +839,7 @@
             <a:fld id="{1D8BD707-D9CF-40AE-B4C6-C98DA3205C09}" type="datetimeFigureOut">
               <a:rPr lang="en-US" smtClean="0"/>
               <a:pPr/>
-              <a:t>6/30/2026</a:t>
+              <a:t>7/10/2026</a:t>
             </a:fld>
             <a:endParaRPr lang="en-US"/>
           </a:p>
@@ -1085,7 +1081,7 @@
             <a:fld id="{1D8BD707-D9CF-40AE-B4C6-C98DA3205C09}" type="datetimeFigureOut">
               <a:rPr lang="en-US" smtClean="0"/>
               <a:pPr/>
-              <a:t>6/30/2026</a:t>
+              <a:t>7/10/2026</a:t>
             </a:fld>
             <a:endParaRPr lang="en-US"/>
           </a:p>
@@ -1367,7 +1363,7 @@
             <a:fld id="{1D8BD707-D9CF-40AE-B4C6-C98DA3205C09}" type="datetimeFigureOut">
               <a:rPr lang="en-US" smtClean="0"/>
               <a:pPr/>
-              <a:t>6/30/2026</a:t>
+              <a:t>7/10/2026</a:t>
             </a:fld>
             <a:endParaRPr lang="en-US"/>
           </a:p>
@@ -1783,7 +1779,7 @@
             <a:fld id="{1D8BD707-D9CF-40AE-B4C6-C98DA3205C09}" type="datetimeFigureOut">
               <a:rPr lang="en-US" smtClean="0"/>
               <a:pPr/>
-              <a:t>6/30/2026</a:t>
+              <a:t>7/10/2026</a:t>
             </a:fld>
             <a:endParaRPr lang="en-US"/>
           </a:p>
@@ -1897,7 +1893,7 @@
             <a:fld id="{1D8BD707-D9CF-40AE-B4C6-C98DA3205C09}" type="datetimeFigureOut">
               <a:rPr lang="en-US" smtClean="0"/>
               <a:pPr/>
-              <a:t>6/30/2026</a:t>
+              <a:t>7/10/2026</a:t>
             </a:fld>
             <a:endParaRPr lang="en-US"/>
           </a:p>
@@ -1989,7 +1985,7 @@
             <a:fld id="{1D8BD707-D9CF-40AE-B4C6-C98DA3205C09}" type="datetimeFigureOut">
               <a:rPr lang="en-US" smtClean="0"/>
               <a:pPr/>
-              <a:t>6/30/2026</a:t>
+              <a:t>7/10/2026</a:t>
             </a:fld>
             <a:endParaRPr lang="en-US"/>
           </a:p>
@@ -2261,7 +2257,7 @@
             <a:fld id="{1D8BD707-D9CF-40AE-B4C6-C98DA3205C09}" type="datetimeFigureOut">
               <a:rPr lang="en-US" smtClean="0"/>
               <a:pPr/>
-              <a:t>6/30/2026</a:t>
+              <a:t>7/10/2026</a:t>
             </a:fld>
             <a:endParaRPr lang="en-US"/>
           </a:p>
@@ -2510,7 +2506,7 @@
             <a:fld id="{1D8BD707-D9CF-40AE-B4C6-C98DA3205C09}" type="datetimeFigureOut">
               <a:rPr lang="en-US" smtClean="0"/>
               <a:pPr/>
-              <a:t>6/30/2026</a:t>
+              <a:t>7/10/2026</a:t>
             </a:fld>
             <a:endParaRPr lang="en-US"/>
           </a:p>
@@ -2718,7 +2714,7 @@
             <a:fld id="{1D8BD707-D9CF-40AE-B4C6-C98DA3205C09}" type="datetimeFigureOut">
               <a:rPr lang="en-US" smtClean="0"/>
               <a:pPr/>
-              <a:t>6/30/2026</a:t>
+              <a:t>7/10/2026</a:t>
             </a:fld>
             <a:endParaRPr lang="en-US"/>
           </a:p>
@@ -7206,7 +7202,7 @@
                   <a:cs typeface="Open Sans Bold Italics"/>
                   <a:sym typeface="Open Sans Bold Italics"/>
                 </a:rPr>
-                <a:t>01</a:t>
+                <a:t>02</a:t>
               </a:r>
             </a:p>
           </p:txBody>
@@ -7304,7 +7300,7 @@
         <p:spPr>
           <a:xfrm>
             <a:off x="2925999" y="4119523"/>
-            <a:ext cx="3679400" cy="3054137"/>
+            <a:ext cx="3679400" cy="3153492"/>
           </a:xfrm>
           <a:prstGeom prst="rect">
             <a:avLst/>
@@ -7322,7 +7318,7 @@
               </a:lnSpc>
             </a:pPr>
             <a:r>
-              <a:rPr lang="en-US" sz="2190">
+              <a:rPr lang="en-US" sz="2190" dirty="0" err="1">
                 <a:solidFill>
                   <a:srgbClr val="000000"/>
                 </a:solidFill>
@@ -7331,8 +7327,41 @@
                 <a:cs typeface="Open Sans"/>
                 <a:sym typeface="Open Sans"/>
               </a:rPr>
-              <a:t>Esteira Profissional</a:t>
-            </a:r>
+              <a:t>Esteira</a:t>
+            </a:r>
+            <a:r>
+              <a:rPr lang="en-US" sz="2190" dirty="0">
+                <a:solidFill>
+                  <a:srgbClr val="000000"/>
+                </a:solidFill>
+                <a:latin typeface="Open Sans"/>
+                <a:ea typeface="Open Sans"/>
+                <a:cs typeface="Open Sans"/>
+                <a:sym typeface="Open Sans"/>
+              </a:rPr>
+              <a:t> </a:t>
+            </a:r>
+            <a:r>
+              <a:rPr lang="en-US" sz="2190" dirty="0" err="1">
+                <a:solidFill>
+                  <a:srgbClr val="000000"/>
+                </a:solidFill>
+                <a:latin typeface="Open Sans"/>
+                <a:ea typeface="Open Sans"/>
+                <a:cs typeface="Open Sans"/>
+                <a:sym typeface="Open Sans"/>
+              </a:rPr>
+              <a:t>Profissional</a:t>
+            </a:r>
+            <a:endParaRPr lang="en-US" sz="2190" dirty="0">
+              <a:solidFill>
+                <a:srgbClr val="000000"/>
+              </a:solidFill>
+              <a:latin typeface="Open Sans"/>
+              <a:ea typeface="Open Sans"/>
+              <a:cs typeface="Open Sans"/>
+              <a:sym typeface="Open Sans"/>
+            </a:endParaRPr>
           </a:p>
           <a:p>
             <a:pPr algn="l">
@@ -7341,7 +7370,7 @@
               </a:lnSpc>
             </a:pPr>
             <a:r>
-              <a:rPr lang="en-US" sz="2190">
+              <a:rPr lang="en-US" sz="2190" dirty="0">
                 <a:solidFill>
                   <a:srgbClr val="000000"/>
                 </a:solidFill>
@@ -7350,8 +7379,29 @@
                 <a:cs typeface="Open Sans"/>
                 <a:sym typeface="Open Sans"/>
               </a:rPr>
-              <a:t>Bicicleta Spinning Magnética</a:t>
-            </a:r>
+              <a:t>Bicicleta Spinning </a:t>
+            </a:r>
+            <a:r>
+              <a:rPr lang="en-US" sz="2190" dirty="0" err="1">
+                <a:solidFill>
+                  <a:srgbClr val="000000"/>
+                </a:solidFill>
+                <a:latin typeface="Open Sans"/>
+                <a:ea typeface="Open Sans"/>
+                <a:cs typeface="Open Sans"/>
+                <a:sym typeface="Open Sans"/>
+              </a:rPr>
+              <a:t>Magnética</a:t>
+            </a:r>
+            <a:endParaRPr lang="en-US" sz="2190" dirty="0">
+              <a:solidFill>
+                <a:srgbClr val="000000"/>
+              </a:solidFill>
+              <a:latin typeface="Open Sans"/>
+              <a:ea typeface="Open Sans"/>
+              <a:cs typeface="Open Sans"/>
+              <a:sym typeface="Open Sans"/>
+            </a:endParaRPr>
           </a:p>
           <a:p>
             <a:pPr algn="l">
@@ -7360,7 +7410,7 @@
               </a:lnSpc>
             </a:pPr>
             <a:r>
-              <a:rPr lang="en-US" sz="2190">
+              <a:rPr lang="en-US" sz="2190" dirty="0" err="1">
                 <a:solidFill>
                   <a:srgbClr val="000000"/>
                 </a:solidFill>
@@ -7369,8 +7419,65 @@
                 <a:cs typeface="Open Sans"/>
                 <a:sym typeface="Open Sans"/>
               </a:rPr>
-              <a:t>Cadeira Extensora / Flexora</a:t>
-            </a:r>
+              <a:t>Cadeira</a:t>
+            </a:r>
+            <a:r>
+              <a:rPr lang="en-US" sz="2190" dirty="0">
+                <a:solidFill>
+                  <a:srgbClr val="000000"/>
+                </a:solidFill>
+                <a:latin typeface="Open Sans"/>
+                <a:ea typeface="Open Sans"/>
+                <a:cs typeface="Open Sans"/>
+                <a:sym typeface="Open Sans"/>
+              </a:rPr>
+              <a:t> </a:t>
+            </a:r>
+            <a:r>
+              <a:rPr lang="en-US" sz="2190" dirty="0" err="1">
+                <a:solidFill>
+                  <a:srgbClr val="000000"/>
+                </a:solidFill>
+                <a:latin typeface="Open Sans"/>
+                <a:ea typeface="Open Sans"/>
+                <a:cs typeface="Open Sans"/>
+                <a:sym typeface="Open Sans"/>
+              </a:rPr>
+              <a:t>Extensora</a:t>
+            </a:r>
+            <a:r>
+              <a:rPr lang="en-US" sz="2190" dirty="0">
+                <a:solidFill>
+                  <a:srgbClr val="000000"/>
+                </a:solidFill>
+                <a:latin typeface="Open Sans"/>
+                <a:ea typeface="Open Sans"/>
+                <a:cs typeface="Open Sans"/>
+                <a:sym typeface="Open Sans"/>
+              </a:rPr>
+              <a:t> / </a:t>
+            </a:r>
+            <a:r>
+              <a:rPr lang="en-US" sz="2190" dirty="0" err="1">
+                <a:solidFill>
+                  <a:srgbClr val="000000"/>
+                </a:solidFill>
+                <a:latin typeface="Open Sans"/>
+                <a:ea typeface="Open Sans"/>
+                <a:cs typeface="Open Sans"/>
+                <a:sym typeface="Open Sans"/>
+              </a:rPr>
+              <a:t>Flexora</a:t>
+            </a:r>
+            <a:endParaRPr lang="en-US" sz="2190" dirty="0">
+              <a:solidFill>
+                <a:srgbClr val="000000"/>
+              </a:solidFill>
+              <a:latin typeface="Open Sans"/>
+              <a:ea typeface="Open Sans"/>
+              <a:cs typeface="Open Sans"/>
+              <a:sym typeface="Open Sans"/>
+            </a:endParaRPr>
           </a:p>
           <a:p>
             <a:pPr algn="l">
@@ -7379,7 +7486,7 @@
               </a:lnSpc>
             </a:pPr>
             <a:r>
-              <a:rPr lang="en-US" sz="2190">
+              <a:rPr lang="en-US" sz="2190" dirty="0" err="1">
                 <a:solidFill>
                   <a:srgbClr val="000000"/>
                 </a:solidFill>
@@ -7388,8 +7495,65 @@
                 <a:cs typeface="Open Sans"/>
                 <a:sym typeface="Open Sans"/>
               </a:rPr>
-              <a:t>Cadeira Adutora e Abdutora</a:t>
-            </a:r>
+              <a:t>Cadeira</a:t>
+            </a:r>
+            <a:r>
+              <a:rPr lang="en-US" sz="2190" dirty="0">
+                <a:solidFill>
+                  <a:srgbClr val="000000"/>
+                </a:solidFill>
+                <a:latin typeface="Open Sans"/>
+                <a:ea typeface="Open Sans"/>
+                <a:cs typeface="Open Sans"/>
+                <a:sym typeface="Open Sans"/>
+              </a:rPr>
+              <a:t> </a:t>
+            </a:r>
+            <a:r>
+              <a:rPr lang="en-US" sz="2190" dirty="0" err="1">
+                <a:solidFill>
+                  <a:srgbClr val="000000"/>
+                </a:solidFill>
+                <a:latin typeface="Open Sans"/>
+                <a:ea typeface="Open Sans"/>
+                <a:cs typeface="Open Sans"/>
+                <a:sym typeface="Open Sans"/>
+              </a:rPr>
+              <a:t>Adutora</a:t>
+            </a:r>
+            <a:r>
+              <a:rPr lang="en-US" sz="2190" dirty="0">
+                <a:solidFill>
+                  <a:srgbClr val="000000"/>
+                </a:solidFill>
+                <a:latin typeface="Open Sans"/>
+                <a:ea typeface="Open Sans"/>
+                <a:cs typeface="Open Sans"/>
+                <a:sym typeface="Open Sans"/>
+              </a:rPr>
+              <a:t> e </a:t>
+            </a:r>
+            <a:r>
+              <a:rPr lang="en-US" sz="2190" dirty="0" err="1">
+                <a:solidFill>
+                  <a:srgbClr val="000000"/>
+                </a:solidFill>
+                <a:latin typeface="Open Sans"/>
+                <a:ea typeface="Open Sans"/>
+                <a:cs typeface="Open Sans"/>
+                <a:sym typeface="Open Sans"/>
+              </a:rPr>
+              <a:t>Abdutora</a:t>
+            </a:r>
+            <a:endParaRPr lang="en-US" sz="2190" dirty="0">
+              <a:solidFill>
+                <a:srgbClr val="000000"/>
+              </a:solidFill>
+              <a:latin typeface="Open Sans"/>
+              <a:ea typeface="Open Sans"/>
+              <a:cs typeface="Open Sans"/>
+              <a:sym typeface="Open Sans"/>
+            </a:endParaRPr>
           </a:p>
           <a:p>
             <a:pPr algn="l">
@@ -7398,7 +7562,7 @@
               </a:lnSpc>
             </a:pPr>
             <a:r>
-              <a:rPr lang="en-US" sz="2190">
+              <a:rPr lang="en-US" sz="2190" dirty="0">
                 <a:solidFill>
                   <a:srgbClr val="000000"/>
                 </a:solidFill>
@@ -7407,8 +7571,29 @@
                 <a:cs typeface="Open Sans"/>
                 <a:sym typeface="Open Sans"/>
               </a:rPr>
-              <a:t>Banco Supino</a:t>
-            </a:r>
+              <a:t>Banco Horizontal </a:t>
+            </a:r>
+            <a:r>
+              <a:rPr lang="en-US" sz="2190" dirty="0" err="1">
+                <a:solidFill>
+                  <a:srgbClr val="000000"/>
+                </a:solidFill>
+                <a:latin typeface="Open Sans"/>
+                <a:ea typeface="Open Sans"/>
+                <a:cs typeface="Open Sans"/>
+                <a:sym typeface="Open Sans"/>
+              </a:rPr>
+              <a:t>Regulável</a:t>
+            </a:r>
+            <a:endParaRPr lang="en-US" sz="2190" dirty="0">
+              <a:solidFill>
+                <a:srgbClr val="000000"/>
+              </a:solidFill>
+              <a:latin typeface="Open Sans"/>
+              <a:ea typeface="Open Sans"/>
+              <a:cs typeface="Open Sans"/>
+              <a:sym typeface="Open Sans"/>
+            </a:endParaRPr>
           </a:p>
           <a:p>
             <a:pPr algn="l">
@@ -7417,7 +7602,7 @@
               </a:lnSpc>
             </a:pPr>
             <a:r>
-              <a:rPr lang="en-US" sz="2190">
+              <a:rPr lang="en-US" sz="2190" dirty="0">
                 <a:solidFill>
                   <a:srgbClr val="000000"/>
                 </a:solidFill>
@@ -7426,7 +7611,7 @@
                 <a:cs typeface="Open Sans"/>
                 <a:sym typeface="Open Sans"/>
               </a:rPr>
-              <a:t>Banco Horizontal Regulável</a:t>
+              <a:t>110kg Halteres 1-10kg</a:t>
             </a:r>
           </a:p>
           <a:p>
@@ -7436,7 +7621,7 @@
               </a:lnSpc>
             </a:pPr>
             <a:r>
-              <a:rPr lang="en-US" sz="2190">
+              <a:rPr lang="en-US" sz="2190" dirty="0">
                 <a:solidFill>
                   <a:srgbClr val="000000"/>
                 </a:solidFill>
@@ -7445,17 +7630,10 @@
                 <a:cs typeface="Open Sans"/>
                 <a:sym typeface="Open Sans"/>
               </a:rPr>
-              <a:t>110kg Halteres 1-10kg</a:t>
-            </a:r>
-          </a:p>
-          <a:p>
-            <a:pPr algn="l">
-              <a:lnSpc>
-                <a:spcPts val="3067"/>
-              </a:lnSpc>
-            </a:pPr>
-            <a:r>
-              <a:rPr lang="en-US" sz="2190">
+              <a:t>100kg </a:t>
+            </a:r>
+            <a:r>
+              <a:rPr lang="en-US" sz="2190" dirty="0" err="1">
                 <a:solidFill>
                   <a:srgbClr val="000000"/>
                 </a:solidFill>
@@ -7464,7 +7642,19 @@
                 <a:cs typeface="Open Sans"/>
                 <a:sym typeface="Open Sans"/>
               </a:rPr>
-              <a:t>100kg Anilhas (1,30/kg)</a:t>
+              <a:t>Anilhas</a:t>
+            </a:r>
+            <a:r>
+              <a:rPr lang="en-US" sz="2190" dirty="0">
+                <a:solidFill>
+                  <a:srgbClr val="000000"/>
+                </a:solidFill>
+                <a:latin typeface="Open Sans"/>
+                <a:ea typeface="Open Sans"/>
+                <a:cs typeface="Open Sans"/>
+                <a:sym typeface="Open Sans"/>
+              </a:rPr>
+              <a:t> (1,30/kg)</a:t>
             </a:r>
           </a:p>
         </p:txBody>
@@ -7699,6 +7889,118 @@
           </a:p>
         </p:txBody>
       </p:sp>
+      <p:grpSp>
+        <p:nvGrpSpPr>
+          <p:cNvPr id="64" name="Group 43">
+            <a:extLst>
+              <a:ext uri="{FF2B5EF4-FFF2-40B4-BE49-F238E27FC236}">
+                <a16:creationId xmlns:a16="http://schemas.microsoft.com/office/drawing/2014/main" id="{0CA95642-C6B7-3E9B-07F2-E64EE50415D6}"/>
+              </a:ext>
+            </a:extLst>
+          </p:cNvPr>
+          <p:cNvGrpSpPr/>
+          <p:nvPr/>
+        </p:nvGrpSpPr>
+        <p:grpSpPr>
+          <a:xfrm>
+            <a:off x="7598382" y="6922810"/>
+            <a:ext cx="326418" cy="278090"/>
+            <a:chOff x="0" y="0"/>
+            <a:chExt cx="62793" cy="73242"/>
+          </a:xfrm>
+        </p:grpSpPr>
+        <p:sp>
+          <p:nvSpPr>
+            <p:cNvPr id="65" name="Freeform 44">
+              <a:extLst>
+                <a:ext uri="{FF2B5EF4-FFF2-40B4-BE49-F238E27FC236}">
+                  <a16:creationId xmlns:a16="http://schemas.microsoft.com/office/drawing/2014/main" id="{6C4346C7-AF8C-861E-C300-7C3639EA5154}"/>
+                </a:ext>
+              </a:extLst>
+            </p:cNvPr>
+            <p:cNvSpPr/>
+            <p:nvPr/>
+          </p:nvSpPr>
+          <p:spPr>
+            <a:xfrm>
+              <a:off x="0" y="0"/>
+              <a:ext cx="62793" cy="73242"/>
+            </a:xfrm>
+            <a:custGeom>
+              <a:avLst/>
+              <a:gdLst/>
+              <a:ahLst/>
+              <a:cxnLst/>
+              <a:rect l="l" t="t" r="r" b="b"/>
+              <a:pathLst>
+                <a:path w="62793" h="73242">
+                  <a:moveTo>
+                    <a:pt x="0" y="0"/>
+                  </a:moveTo>
+                  <a:lnTo>
+                    <a:pt x="62793" y="0"/>
+                  </a:lnTo>
+                  <a:lnTo>
+                    <a:pt x="62793" y="73242"/>
+                  </a:lnTo>
+                  <a:lnTo>
+                    <a:pt x="0" y="73242"/>
+                  </a:lnTo>
+                  <a:close/>
+                </a:path>
+              </a:pathLst>
+            </a:custGeom>
+            <a:solidFill>
+              <a:srgbClr val="FFD300"/>
+            </a:solidFill>
+          </p:spPr>
+        </p:sp>
+        <p:sp>
+          <p:nvSpPr>
+            <p:cNvPr id="66" name="TextBox 45">
+              <a:extLst>
+                <a:ext uri="{FF2B5EF4-FFF2-40B4-BE49-F238E27FC236}">
+                  <a16:creationId xmlns:a16="http://schemas.microsoft.com/office/drawing/2014/main" id="{DC7A35C8-9002-E4F5-F1B0-1EC26C0B5FD2}"/>
+                </a:ext>
+              </a:extLst>
+            </p:cNvPr>
+            <p:cNvSpPr txBox="1"/>
+            <p:nvPr/>
+          </p:nvSpPr>
+          <p:spPr>
+            <a:xfrm>
+              <a:off x="0" y="-19050"/>
+              <a:ext cx="62793" cy="92292"/>
+            </a:xfrm>
+            <a:prstGeom prst="rect">
+              <a:avLst/>
+            </a:prstGeom>
+          </p:spPr>
+          <p:txBody>
+            <a:bodyPr lIns="50800" tIns="50800" rIns="50800" bIns="50800" rtlCol="0" anchor="ctr"/>
+            <a:lstStyle/>
+            <a:p>
+              <a:pPr algn="ctr">
+                <a:lnSpc>
+                  <a:spcPts val="1387"/>
+                </a:lnSpc>
+              </a:pPr>
+              <a:r>
+                <a:rPr lang="en-US" sz="990" b="1" i="1">
+                  <a:solidFill>
+                    <a:srgbClr val="000000"/>
+                  </a:solidFill>
+                  <a:latin typeface="Open Sans Bold Italics"/>
+                  <a:ea typeface="Open Sans Bold Italics"/>
+                  <a:cs typeface="Open Sans Bold Italics"/>
+                  <a:sym typeface="Open Sans Bold Italics"/>
+                </a:rPr>
+                <a:t>01</a:t>
+              </a:r>
+            </a:p>
+          </p:txBody>
+        </p:sp>
+      </p:grpSp>
     </p:spTree>
   </p:cSld>
   <p:clrMapOvr>
@@ -8169,8 +8471,8 @@
         </p:nvSpPr>
         <p:spPr>
           <a:xfrm>
-            <a:off x="9863310" y="2085223"/>
-            <a:ext cx="7395990" cy="7517571"/>
+            <a:off x="9863310" y="876300"/>
+            <a:ext cx="7395990" cy="8710205"/>
           </a:xfrm>
           <a:prstGeom prst="rect">
             <a:avLst/>
@@ -8535,6 +8837,81 @@
                 <a:sym typeface="Open Sans Bold Italics"/>
               </a:rPr>
               <a:t>- [PROMO_VALOR]</a:t>
+            </a:r>
+          </a:p>
+          <a:p>
+            <a:pPr>
+              <a:lnSpc>
+                <a:spcPts val="3067"/>
+              </a:lnSpc>
+              <a:spcBef>
+                <a:spcPct val="0"/>
+              </a:spcBef>
+            </a:pPr>
+            <a:endParaRPr lang="en-US" sz="2190" b="1" i="1" dirty="0">
+              <a:solidFill>
+                <a:srgbClr val="FFD300"/>
+              </a:solidFill>
+              <a:latin typeface="Open Sans Bold Italics"/>
+              <a:ea typeface="Open Sans Bold Italics"/>
+              <a:cs typeface="Open Sans Bold Italics"/>
+              <a:sym typeface="Open Sans Bold Italics"/>
+            </a:endParaRPr>
+          </a:p>
+          <a:p>
+            <a:pPr>
+              <a:lnSpc>
+                <a:spcPts val="3067"/>
+              </a:lnSpc>
+              <a:spcBef>
+                <a:spcPct val="0"/>
+              </a:spcBef>
+            </a:pPr>
+            <a:r>
+              <a:rPr lang="en-US" sz="2190" b="1" i="1" dirty="0" err="1">
+                <a:solidFill>
+                  <a:srgbClr val="FFD300"/>
+                </a:solidFill>
+                <a:latin typeface="Open Sans Bold Italics"/>
+                <a:ea typeface="Open Sans Bold Italics"/>
+                <a:cs typeface="Open Sans Bold Italics"/>
+                <a:sym typeface="Open Sans Bold Italics"/>
+              </a:rPr>
+              <a:t>Equipamentos</a:t>
+            </a:r>
+            <a:r>
+              <a:rPr lang="en-US" sz="2190" b="1" i="1" dirty="0">
+                <a:solidFill>
+                  <a:srgbClr val="FFD300"/>
+                </a:solidFill>
+                <a:latin typeface="Open Sans Bold Italics"/>
+                <a:ea typeface="Open Sans Bold Italics"/>
+                <a:cs typeface="Open Sans Bold Italics"/>
+                <a:sym typeface="Open Sans Bold Italics"/>
+              </a:rPr>
+              <a:t> Extras:</a:t>
+            </a:r>
+          </a:p>
+          <a:p>
+            <a:pPr>
+              <a:lnSpc>
+                <a:spcPts val="3067"/>
+              </a:lnSpc>
+              <a:spcBef>
+                <a:spcPct val="0"/>
+              </a:spcBef>
+            </a:pPr>
+            <a:r>
+              <a:rPr lang="en-US" sz="2190" b="1" i="1" dirty="0">
+                <a:solidFill>
+                  <a:srgbClr val="FFD300"/>
+                </a:solidFill>
+                <a:latin typeface="Open Sans Bold Italics"/>
+                <a:ea typeface="Open Sans Bold Italics"/>
+                <a:cs typeface="Open Sans Bold Italics"/>
+                <a:sym typeface="Open Sans Bold Italics"/>
+              </a:rPr>
+              <a:t>[EQUIP_EXTRA]: [EQUIP_EXTRA_QUANT]</a:t>
             </a:r>
           </a:p>
           <a:p>

</xml_diff>

<commit_message>
Ajuste no período promocional
</commit_message>
<xml_diff>
--- a/simulador_duofitness/templates/uno.pptx
+++ b/simulador_duofitness/templates/uno.pptx
@@ -338,7 +338,7 @@
             <a:fld id="{1D8BD707-D9CF-40AE-B4C6-C98DA3205C09}" type="datetimeFigureOut">
               <a:rPr lang="en-US" smtClean="0"/>
               <a:pPr/>
-              <a:t>7/10/2026</a:t>
+              <a:t>7/16/2026</a:t>
             </a:fld>
             <a:endParaRPr lang="en-US"/>
           </a:p>
@@ -503,7 +503,7 @@
             <a:fld id="{1D8BD707-D9CF-40AE-B4C6-C98DA3205C09}" type="datetimeFigureOut">
               <a:rPr lang="en-US" smtClean="0"/>
               <a:pPr/>
-              <a:t>7/10/2026</a:t>
+              <a:t>7/16/2026</a:t>
             </a:fld>
             <a:endParaRPr lang="en-US"/>
           </a:p>
@@ -678,7 +678,7 @@
             <a:fld id="{1D8BD707-D9CF-40AE-B4C6-C98DA3205C09}" type="datetimeFigureOut">
               <a:rPr lang="en-US" smtClean="0"/>
               <a:pPr/>
-              <a:t>7/10/2026</a:t>
+              <a:t>7/16/2026</a:t>
             </a:fld>
             <a:endParaRPr lang="en-US"/>
           </a:p>
@@ -843,7 +843,7 @@
             <a:fld id="{1D8BD707-D9CF-40AE-B4C6-C98DA3205C09}" type="datetimeFigureOut">
               <a:rPr lang="en-US" smtClean="0"/>
               <a:pPr/>
-              <a:t>7/10/2026</a:t>
+              <a:t>7/16/2026</a:t>
             </a:fld>
             <a:endParaRPr lang="en-US"/>
           </a:p>
@@ -1085,7 +1085,7 @@
             <a:fld id="{1D8BD707-D9CF-40AE-B4C6-C98DA3205C09}" type="datetimeFigureOut">
               <a:rPr lang="en-US" smtClean="0"/>
               <a:pPr/>
-              <a:t>7/10/2026</a:t>
+              <a:t>7/16/2026</a:t>
             </a:fld>
             <a:endParaRPr lang="en-US"/>
           </a:p>
@@ -1367,7 +1367,7 @@
             <a:fld id="{1D8BD707-D9CF-40AE-B4C6-C98DA3205C09}" type="datetimeFigureOut">
               <a:rPr lang="en-US" smtClean="0"/>
               <a:pPr/>
-              <a:t>7/10/2026</a:t>
+              <a:t>7/16/2026</a:t>
             </a:fld>
             <a:endParaRPr lang="en-US"/>
           </a:p>
@@ -1783,7 +1783,7 @@
             <a:fld id="{1D8BD707-D9CF-40AE-B4C6-C98DA3205C09}" type="datetimeFigureOut">
               <a:rPr lang="en-US" smtClean="0"/>
               <a:pPr/>
-              <a:t>7/10/2026</a:t>
+              <a:t>7/16/2026</a:t>
             </a:fld>
             <a:endParaRPr lang="en-US"/>
           </a:p>
@@ -1897,7 +1897,7 @@
             <a:fld id="{1D8BD707-D9CF-40AE-B4C6-C98DA3205C09}" type="datetimeFigureOut">
               <a:rPr lang="en-US" smtClean="0"/>
               <a:pPr/>
-              <a:t>7/10/2026</a:t>
+              <a:t>7/16/2026</a:t>
             </a:fld>
             <a:endParaRPr lang="en-US"/>
           </a:p>
@@ -1989,7 +1989,7 @@
             <a:fld id="{1D8BD707-D9CF-40AE-B4C6-C98DA3205C09}" type="datetimeFigureOut">
               <a:rPr lang="en-US" smtClean="0"/>
               <a:pPr/>
-              <a:t>7/10/2026</a:t>
+              <a:t>7/16/2026</a:t>
             </a:fld>
             <a:endParaRPr lang="en-US"/>
           </a:p>
@@ -2261,7 +2261,7 @@
             <a:fld id="{1D8BD707-D9CF-40AE-B4C6-C98DA3205C09}" type="datetimeFigureOut">
               <a:rPr lang="en-US" smtClean="0"/>
               <a:pPr/>
-              <a:t>7/10/2026</a:t>
+              <a:t>7/16/2026</a:t>
             </a:fld>
             <a:endParaRPr lang="en-US"/>
           </a:p>
@@ -2510,7 +2510,7 @@
             <a:fld id="{1D8BD707-D9CF-40AE-B4C6-C98DA3205C09}" type="datetimeFigureOut">
               <a:rPr lang="en-US" smtClean="0"/>
               <a:pPr/>
-              <a:t>7/10/2026</a:t>
+              <a:t>7/16/2026</a:t>
             </a:fld>
             <a:endParaRPr lang="en-US"/>
           </a:p>
@@ -2718,7 +2718,7 @@
             <a:fld id="{1D8BD707-D9CF-40AE-B4C6-C98DA3205C09}" type="datetimeFigureOut">
               <a:rPr lang="en-US" smtClean="0"/>
               <a:pPr/>
-              <a:t>7/10/2026</a:t>
+              <a:t>7/16/2026</a:t>
             </a:fld>
             <a:endParaRPr lang="en-US"/>
           </a:p>
@@ -8044,7 +8044,7 @@
         </p:nvGrpSpPr>
         <p:grpSpPr>
           <a:xfrm>
-            <a:off x="9677048" y="7810500"/>
+            <a:off x="9525000" y="5829300"/>
             <a:ext cx="6611142" cy="685611"/>
             <a:chOff x="0" y="0"/>
             <a:chExt cx="1741206" cy="180572"/>
@@ -8269,8 +8269,8 @@
         </p:nvSpPr>
         <p:spPr>
           <a:xfrm>
-            <a:off x="9863310" y="876300"/>
-            <a:ext cx="7395990" cy="8710205"/>
+            <a:off x="9672810" y="1638300"/>
+            <a:ext cx="7395990" cy="5927392"/>
           </a:xfrm>
           <a:prstGeom prst="rect">
             <a:avLst/>
@@ -8543,204 +8543,6 @@
               </a:spcBef>
             </a:pPr>
             <a:r>
-              <a:rPr lang="en-US" sz="2190" b="1" i="1" dirty="0" err="1">
-                <a:solidFill>
-                  <a:srgbClr val="FFD300"/>
-                </a:solidFill>
-                <a:latin typeface="Open Sans Bold Italics"/>
-                <a:ea typeface="Open Sans Bold Italics"/>
-                <a:cs typeface="Open Sans Bold Italics"/>
-                <a:sym typeface="Open Sans Bold Italics"/>
-              </a:rPr>
-              <a:t>Período</a:t>
-            </a:r>
-            <a:r>
-              <a:rPr lang="en-US" sz="2190" b="1" i="1" dirty="0">
-                <a:solidFill>
-                  <a:srgbClr val="FFD300"/>
-                </a:solidFill>
-                <a:latin typeface="Open Sans Bold Italics"/>
-                <a:ea typeface="Open Sans Bold Italics"/>
-                <a:cs typeface="Open Sans Bold Italics"/>
-                <a:sym typeface="Open Sans Bold Italics"/>
-              </a:rPr>
-              <a:t> </a:t>
-            </a:r>
-            <a:r>
-              <a:rPr lang="en-US" sz="2190" b="1" i="1" dirty="0" err="1">
-                <a:solidFill>
-                  <a:srgbClr val="FFD300"/>
-                </a:solidFill>
-                <a:latin typeface="Open Sans Bold Italics"/>
-                <a:ea typeface="Open Sans Bold Italics"/>
-                <a:cs typeface="Open Sans Bold Italics"/>
-                <a:sym typeface="Open Sans Bold Italics"/>
-              </a:rPr>
-              <a:t>Promocional</a:t>
-            </a:r>
-            <a:r>
-              <a:rPr lang="en-US" sz="2190" b="1" i="1" dirty="0">
-                <a:solidFill>
-                  <a:srgbClr val="FFD300"/>
-                </a:solidFill>
-                <a:latin typeface="Open Sans Bold Italics"/>
-                <a:ea typeface="Open Sans Bold Italics"/>
-                <a:cs typeface="Open Sans Bold Italics"/>
-                <a:sym typeface="Open Sans Bold Italics"/>
-              </a:rPr>
-              <a:t>:</a:t>
-            </a:r>
-            <a:br>
-              <a:rPr lang="en-US" sz="2190" b="1" i="1" dirty="0">
-                <a:solidFill>
-                  <a:srgbClr val="FFD300"/>
-                </a:solidFill>
-                <a:latin typeface="Open Sans Bold Italics"/>
-                <a:ea typeface="Open Sans Bold Italics"/>
-                <a:cs typeface="Open Sans Bold Italics"/>
-                <a:sym typeface="Open Sans Bold Italics"/>
-              </a:rPr>
-            </a:br>
-            <a:r>
-              <a:rPr lang="en-US" sz="2190" b="1" i="1" dirty="0">
-                <a:solidFill>
-                  <a:srgbClr val="FFD300"/>
-                </a:solidFill>
-                <a:latin typeface="Open Sans Bold Italics"/>
-                <a:ea typeface="Open Sans Bold Italics"/>
-                <a:cs typeface="Open Sans Bold Italics"/>
-                <a:sym typeface="Open Sans Bold Italics"/>
-              </a:rPr>
-              <a:t>- [PROMO_MES]</a:t>
-            </a:r>
-            <a:br>
-              <a:rPr lang="en-US" sz="2190" b="1" i="1" dirty="0">
-                <a:solidFill>
-                  <a:srgbClr val="FFD300"/>
-                </a:solidFill>
-                <a:latin typeface="Open Sans Bold Italics"/>
-                <a:ea typeface="Open Sans Bold Italics"/>
-                <a:cs typeface="Open Sans Bold Italics"/>
-                <a:sym typeface="Open Sans Bold Italics"/>
-              </a:rPr>
-            </a:br>
-            <a:r>
-              <a:rPr lang="en-US" sz="2190" b="1" i="1" dirty="0">
-                <a:solidFill>
-                  <a:srgbClr val="FFD300"/>
-                </a:solidFill>
-                <a:latin typeface="Open Sans Bold Italics"/>
-                <a:ea typeface="Open Sans Bold Italics"/>
-                <a:cs typeface="Open Sans Bold Italics"/>
-                <a:sym typeface="Open Sans Bold Italics"/>
-              </a:rPr>
-              <a:t>- [PROMO_VALOR]</a:t>
-            </a:r>
-          </a:p>
-          <a:p>
-            <a:pPr>
-              <a:lnSpc>
-                <a:spcPts val="3067"/>
-              </a:lnSpc>
-              <a:spcBef>
-                <a:spcPct val="0"/>
-              </a:spcBef>
-            </a:pPr>
-            <a:endParaRPr lang="en-US" sz="2190" b="1" i="1" dirty="0">
-              <a:solidFill>
-                <a:srgbClr val="FFD300"/>
-              </a:solidFill>
-              <a:latin typeface="Open Sans Bold Italics"/>
-              <a:ea typeface="Open Sans Bold Italics"/>
-              <a:cs typeface="Open Sans Bold Italics"/>
-              <a:sym typeface="Open Sans Bold Italics"/>
-            </a:endParaRPr>
-          </a:p>
-          <a:p>
-            <a:pPr>
-              <a:lnSpc>
-                <a:spcPts val="3067"/>
-              </a:lnSpc>
-              <a:spcBef>
-                <a:spcPct val="0"/>
-              </a:spcBef>
-            </a:pPr>
-            <a:r>
-              <a:rPr lang="en-US" sz="2190" b="1" i="1" dirty="0" err="1">
-                <a:solidFill>
-                  <a:srgbClr val="FFD300"/>
-                </a:solidFill>
-                <a:latin typeface="Open Sans Bold Italics"/>
-                <a:ea typeface="Open Sans Bold Italics"/>
-                <a:cs typeface="Open Sans Bold Italics"/>
-                <a:sym typeface="Open Sans Bold Italics"/>
-              </a:rPr>
-              <a:t>Equipamentos</a:t>
-            </a:r>
-            <a:r>
-              <a:rPr lang="en-US" sz="2190" b="1" i="1" dirty="0">
-                <a:solidFill>
-                  <a:srgbClr val="FFD300"/>
-                </a:solidFill>
-                <a:latin typeface="Open Sans Bold Italics"/>
-                <a:ea typeface="Open Sans Bold Italics"/>
-                <a:cs typeface="Open Sans Bold Italics"/>
-                <a:sym typeface="Open Sans Bold Italics"/>
-              </a:rPr>
-              <a:t> Extras:</a:t>
-            </a:r>
-          </a:p>
-          <a:p>
-            <a:pPr>
-              <a:lnSpc>
-                <a:spcPts val="3067"/>
-              </a:lnSpc>
-              <a:spcBef>
-                <a:spcPct val="0"/>
-              </a:spcBef>
-            </a:pPr>
-            <a:r>
-              <a:rPr lang="en-US" sz="2190" b="1" i="1" dirty="0">
-                <a:solidFill>
-                  <a:srgbClr val="FFD300"/>
-                </a:solidFill>
-                <a:latin typeface="Open Sans Bold Italics"/>
-                <a:ea typeface="Open Sans Bold Italics"/>
-                <a:cs typeface="Open Sans Bold Italics"/>
-                <a:sym typeface="Open Sans Bold Italics"/>
-              </a:rPr>
-              <a:t>[EQUIP_EXTRA]</a:t>
-            </a:r>
-          </a:p>
-          <a:p>
-            <a:pPr>
-              <a:lnSpc>
-                <a:spcPts val="3067"/>
-              </a:lnSpc>
-              <a:spcBef>
-                <a:spcPct val="0"/>
-              </a:spcBef>
-            </a:pPr>
-            <a:endParaRPr lang="en-US" sz="2190" b="1" i="1" dirty="0">
-              <a:solidFill>
-                <a:srgbClr val="FFD300"/>
-              </a:solidFill>
-              <a:latin typeface="Open Sans Bold Italics"/>
-              <a:ea typeface="Open Sans Bold Italics"/>
-              <a:cs typeface="Open Sans Bold Italics"/>
-              <a:sym typeface="Open Sans Bold Italics"/>
-            </a:endParaRPr>
-          </a:p>
-          <a:p>
-            <a:pPr>
-              <a:lnSpc>
-                <a:spcPts val="3067"/>
-              </a:lnSpc>
-              <a:spcBef>
-                <a:spcPct val="0"/>
-              </a:spcBef>
-            </a:pPr>
-            <a:r>
               <a:rPr lang="en-US" sz="2190" dirty="0" err="1">
                 <a:solidFill>
                   <a:srgbClr val="FFFFFF"/>
@@ -9265,6 +9067,139 @@
                 <a:sym typeface="Open Sans Bold Italics"/>
               </a:rPr>
               <a:t>.</a:t>
+            </a:r>
+          </a:p>
+        </p:txBody>
+      </p:sp>
+      <p:sp>
+        <p:nvSpPr>
+          <p:cNvPr id="17" name="TextBox 16">
+            <a:extLst>
+              <a:ext uri="{FF2B5EF4-FFF2-40B4-BE49-F238E27FC236}">
+                <a16:creationId xmlns:a16="http://schemas.microsoft.com/office/drawing/2014/main" id="{0A374C91-F5F7-0D9B-9A12-5F4BEA9B1C57}"/>
+              </a:ext>
+            </a:extLst>
+          </p:cNvPr>
+          <p:cNvSpPr txBox="1"/>
+          <p:nvPr/>
+        </p:nvSpPr>
+        <p:spPr>
+          <a:xfrm>
+            <a:off x="9635939" y="7886700"/>
+            <a:ext cx="9144000" cy="1249188"/>
+          </a:xfrm>
+          <a:prstGeom prst="rect">
+            <a:avLst/>
+          </a:prstGeom>
+          <a:noFill/>
+        </p:spPr>
+        <p:txBody>
+          <a:bodyPr wrap="square">
+            <a:spAutoFit/>
+          </a:bodyPr>
+          <a:lstStyle/>
+          <a:p>
+            <a:pPr>
+              <a:lnSpc>
+                <a:spcPts val="3067"/>
+              </a:lnSpc>
+              <a:spcBef>
+                <a:spcPct val="0"/>
+              </a:spcBef>
+            </a:pPr>
+            <a:r>
+              <a:rPr lang="en-US" sz="2190" b="1" i="1" dirty="0" err="1">
+                <a:solidFill>
+                  <a:srgbClr val="FFD300"/>
+                </a:solidFill>
+                <a:latin typeface="Open Sans Bold Italics"/>
+                <a:ea typeface="Open Sans Bold Italics"/>
+                <a:cs typeface="Open Sans Bold Italics"/>
+                <a:sym typeface="Open Sans Bold Italics"/>
+              </a:rPr>
+              <a:t>Período</a:t>
+            </a:r>
+            <a:r>
+              <a:rPr lang="en-US" sz="2190" b="1" i="1" dirty="0">
+                <a:solidFill>
+                  <a:srgbClr val="FFD300"/>
+                </a:solidFill>
+                <a:latin typeface="Open Sans Bold Italics"/>
+                <a:ea typeface="Open Sans Bold Italics"/>
+                <a:cs typeface="Open Sans Bold Italics"/>
+                <a:sym typeface="Open Sans Bold Italics"/>
+              </a:rPr>
+              <a:t> </a:t>
+            </a:r>
+            <a:r>
+              <a:rPr lang="en-US" sz="2190" b="1" i="1" dirty="0" err="1">
+                <a:solidFill>
+                  <a:srgbClr val="FFD300"/>
+                </a:solidFill>
+                <a:latin typeface="Open Sans Bold Italics"/>
+                <a:ea typeface="Open Sans Bold Italics"/>
+                <a:cs typeface="Open Sans Bold Italics"/>
+                <a:sym typeface="Open Sans Bold Italics"/>
+              </a:rPr>
+              <a:t>Promocional</a:t>
+            </a:r>
+            <a:r>
+              <a:rPr lang="en-US" sz="2190" b="1" i="1" dirty="0">
+                <a:solidFill>
+                  <a:srgbClr val="FFD300"/>
+                </a:solidFill>
+                <a:latin typeface="Open Sans Bold Italics"/>
+                <a:ea typeface="Open Sans Bold Italics"/>
+                <a:cs typeface="Open Sans Bold Italics"/>
+                <a:sym typeface="Open Sans Bold Italics"/>
+              </a:rPr>
+              <a:t>:</a:t>
+            </a:r>
+            <a:br>
+              <a:rPr lang="en-US" sz="2190" b="1" i="1" dirty="0">
+                <a:solidFill>
+                  <a:srgbClr val="FFD300"/>
+                </a:solidFill>
+                <a:latin typeface="Open Sans Bold Italics"/>
+                <a:ea typeface="Open Sans Bold Italics"/>
+                <a:cs typeface="Open Sans Bold Italics"/>
+                <a:sym typeface="Open Sans Bold Italics"/>
+              </a:rPr>
+            </a:br>
+            <a:r>
+              <a:rPr lang="en-US" sz="2190" b="1" i="1" dirty="0">
+                <a:solidFill>
+                  <a:srgbClr val="FFD300"/>
+                </a:solidFill>
+                <a:latin typeface="Open Sans Bold Italics"/>
+                <a:ea typeface="Open Sans Bold Italics"/>
+                <a:cs typeface="Open Sans Bold Italics"/>
+                <a:sym typeface="Open Sans Bold Italics"/>
+              </a:rPr>
+              <a:t>- [PROMO_MES]</a:t>
+            </a:r>
+            <a:br>
+              <a:rPr lang="en-US" sz="2190" b="1" i="1" dirty="0">
+                <a:solidFill>
+                  <a:srgbClr val="FFD300"/>
+                </a:solidFill>
+                <a:latin typeface="Open Sans Bold Italics"/>
+                <a:ea typeface="Open Sans Bold Italics"/>
+                <a:cs typeface="Open Sans Bold Italics"/>
+                <a:sym typeface="Open Sans Bold Italics"/>
+              </a:rPr>
+            </a:br>
+            <a:r>
+              <a:rPr lang="en-US" sz="2190" b="1" i="1" dirty="0">
+                <a:solidFill>
+                  <a:srgbClr val="FFD300"/>
+                </a:solidFill>
+                <a:latin typeface="Open Sans Bold Italics"/>
+                <a:ea typeface="Open Sans Bold Italics"/>
+                <a:cs typeface="Open Sans Bold Italics"/>
+                <a:sym typeface="Open Sans Bold Italics"/>
+              </a:rPr>
+              <a:t>- [PROMO_VALOR]</a:t>
             </a:r>
           </a:p>
         </p:txBody>

</xml_diff>

<commit_message>
Ajuste de inserção de equipamento extra
</commit_message>
<xml_diff>
--- a/simulador_duofitness/templates/uno.pptx
+++ b/simulador_duofitness/templates/uno.pptx
@@ -27,21 +27,18 @@
     <p:sldId id="283" r:id="rId21"/>
     <p:sldId id="279" r:id="rId22"/>
     <p:sldId id="280" r:id="rId23"/>
-    <p:sldId id="281" r:id="rId24"/>
-    <p:sldId id="282" r:id="rId25"/>
+    <p:sldId id="284" r:id="rId24"/>
+    <p:sldId id="281" r:id="rId25"/>
+    <p:sldId id="282" r:id="rId26"/>
   </p:sldIdLst>
   <p:sldSz cx="18288000" cy="10287000"/>
   <p:notesSz cx="6858000" cy="9144000"/>
   <p:embeddedFontLst>
     <p:embeddedFont>
-      <p:font typeface="Open Sans" pitchFamily="2" charset="0"/>
-      <p:regular r:id="rId26"/>
-      <p:bold r:id="rId27"/>
-      <p:boldItalic r:id="rId28"/>
-    </p:embeddedFont>
-    <p:embeddedFont>
-      <p:font typeface="Open Sans Bold" pitchFamily="2" charset="0"/>
-      <p:bold r:id="rId29"/>
+      <p:font typeface="Open Sans" panose="020B0806030504020204" pitchFamily="34" charset="0"/>
+      <p:regular r:id="rId27"/>
+      <p:bold r:id="rId28"/>
+      <p:boldItalic r:id="rId29"/>
     </p:embeddedFont>
   </p:embeddedFontLst>
   <p:defaultTextStyle>
@@ -338,7 +335,7 @@
             <a:fld id="{1D8BD707-D9CF-40AE-B4C6-C98DA3205C09}" type="datetimeFigureOut">
               <a:rPr lang="en-US" smtClean="0"/>
               <a:pPr/>
-              <a:t>7/20/2026</a:t>
+              <a:t>8/4/2026</a:t>
             </a:fld>
             <a:endParaRPr lang="en-US"/>
           </a:p>
@@ -503,7 +500,7 @@
             <a:fld id="{1D8BD707-D9CF-40AE-B4C6-C98DA3205C09}" type="datetimeFigureOut">
               <a:rPr lang="en-US" smtClean="0"/>
               <a:pPr/>
-              <a:t>7/20/2026</a:t>
+              <a:t>8/4/2026</a:t>
             </a:fld>
             <a:endParaRPr lang="en-US"/>
           </a:p>
@@ -678,7 +675,7 @@
             <a:fld id="{1D8BD707-D9CF-40AE-B4C6-C98DA3205C09}" type="datetimeFigureOut">
               <a:rPr lang="en-US" smtClean="0"/>
               <a:pPr/>
-              <a:t>7/20/2026</a:t>
+              <a:t>8/4/2026</a:t>
             </a:fld>
             <a:endParaRPr lang="en-US"/>
           </a:p>
@@ -843,7 +840,7 @@
             <a:fld id="{1D8BD707-D9CF-40AE-B4C6-C98DA3205C09}" type="datetimeFigureOut">
               <a:rPr lang="en-US" smtClean="0"/>
               <a:pPr/>
-              <a:t>7/20/2026</a:t>
+              <a:t>8/4/2026</a:t>
             </a:fld>
             <a:endParaRPr lang="en-US"/>
           </a:p>
@@ -1085,7 +1082,7 @@
             <a:fld id="{1D8BD707-D9CF-40AE-B4C6-C98DA3205C09}" type="datetimeFigureOut">
               <a:rPr lang="en-US" smtClean="0"/>
               <a:pPr/>
-              <a:t>7/20/2026</a:t>
+              <a:t>8/4/2026</a:t>
             </a:fld>
             <a:endParaRPr lang="en-US"/>
           </a:p>
@@ -1367,7 +1364,7 @@
             <a:fld id="{1D8BD707-D9CF-40AE-B4C6-C98DA3205C09}" type="datetimeFigureOut">
               <a:rPr lang="en-US" smtClean="0"/>
               <a:pPr/>
-              <a:t>7/20/2026</a:t>
+              <a:t>8/4/2026</a:t>
             </a:fld>
             <a:endParaRPr lang="en-US"/>
           </a:p>
@@ -1783,7 +1780,7 @@
             <a:fld id="{1D8BD707-D9CF-40AE-B4C6-C98DA3205C09}" type="datetimeFigureOut">
               <a:rPr lang="en-US" smtClean="0"/>
               <a:pPr/>
-              <a:t>7/20/2026</a:t>
+              <a:t>8/4/2026</a:t>
             </a:fld>
             <a:endParaRPr lang="en-US"/>
           </a:p>
@@ -1897,7 +1894,7 @@
             <a:fld id="{1D8BD707-D9CF-40AE-B4C6-C98DA3205C09}" type="datetimeFigureOut">
               <a:rPr lang="en-US" smtClean="0"/>
               <a:pPr/>
-              <a:t>7/20/2026</a:t>
+              <a:t>8/4/2026</a:t>
             </a:fld>
             <a:endParaRPr lang="en-US"/>
           </a:p>
@@ -1989,7 +1986,7 @@
             <a:fld id="{1D8BD707-D9CF-40AE-B4C6-C98DA3205C09}" type="datetimeFigureOut">
               <a:rPr lang="en-US" smtClean="0"/>
               <a:pPr/>
-              <a:t>7/20/2026</a:t>
+              <a:t>8/4/2026</a:t>
             </a:fld>
             <a:endParaRPr lang="en-US"/>
           </a:p>
@@ -2261,7 +2258,7 @@
             <a:fld id="{1D8BD707-D9CF-40AE-B4C6-C98DA3205C09}" type="datetimeFigureOut">
               <a:rPr lang="en-US" smtClean="0"/>
               <a:pPr/>
-              <a:t>7/20/2026</a:t>
+              <a:t>8/4/2026</a:t>
             </a:fld>
             <a:endParaRPr lang="en-US"/>
           </a:p>
@@ -2510,7 +2507,7 @@
             <a:fld id="{1D8BD707-D9CF-40AE-B4C6-C98DA3205C09}" type="datetimeFigureOut">
               <a:rPr lang="en-US" smtClean="0"/>
               <a:pPr/>
-              <a:t>7/20/2026</a:t>
+              <a:t>8/4/2026</a:t>
             </a:fld>
             <a:endParaRPr lang="en-US"/>
           </a:p>
@@ -2718,7 +2715,7 @@
             <a:fld id="{1D8BD707-D9CF-40AE-B4C6-C98DA3205C09}" type="datetimeFigureOut">
               <a:rPr lang="en-US" smtClean="0"/>
               <a:pPr/>
-              <a:t>7/20/2026</a:t>
+              <a:t>8/4/2026</a:t>
             </a:fld>
             <a:endParaRPr lang="en-US"/>
           </a:p>
@@ -5780,6 +5777,447 @@
   <p:cSld>
     <p:spTree>
       <p:nvGrpSpPr>
+        <p:cNvPr id="1" name="">
+          <a:extLst>
+            <a:ext uri="{FF2B5EF4-FFF2-40B4-BE49-F238E27FC236}">
+              <a16:creationId xmlns:a16="http://schemas.microsoft.com/office/drawing/2014/main" id="{BF2768D2-FC0A-1E57-786B-45FF4F3B8FFA}"/>
+            </a:ext>
+          </a:extLst>
+        </p:cNvPr>
+        <p:cNvGrpSpPr/>
+        <p:nvPr/>
+      </p:nvGrpSpPr>
+      <p:grpSpPr>
+        <a:xfrm>
+          <a:off x="0" y="0"/>
+          <a:ext cx="0" cy="0"/>
+          <a:chOff x="0" y="0"/>
+          <a:chExt cx="0" cy="0"/>
+        </a:xfrm>
+      </p:grpSpPr>
+      <p:sp>
+        <p:nvSpPr>
+          <p:cNvPr id="2" name="Freeform 2">
+            <a:extLst>
+              <a:ext uri="{FF2B5EF4-FFF2-40B4-BE49-F238E27FC236}">
+                <a16:creationId xmlns:a16="http://schemas.microsoft.com/office/drawing/2014/main" id="{764C2E68-9509-F89B-BE25-6DDFE2B46331}"/>
+              </a:ext>
+            </a:extLst>
+          </p:cNvPr>
+          <p:cNvSpPr/>
+          <p:nvPr/>
+        </p:nvSpPr>
+        <p:spPr>
+          <a:xfrm>
+            <a:off x="0" y="0"/>
+            <a:ext cx="18288000" cy="10287000"/>
+          </a:xfrm>
+          <a:custGeom>
+            <a:avLst/>
+            <a:gdLst/>
+            <a:ahLst/>
+            <a:cxnLst/>
+            <a:rect l="l" t="t" r="r" b="b"/>
+            <a:pathLst>
+              <a:path w="18288000" h="10287000">
+                <a:moveTo>
+                  <a:pt x="0" y="0"/>
+                </a:moveTo>
+                <a:lnTo>
+                  <a:pt x="18288000" y="0"/>
+                </a:lnTo>
+                <a:lnTo>
+                  <a:pt x="18288000" y="10287000"/>
+                </a:lnTo>
+                <a:lnTo>
+                  <a:pt x="0" y="10287000"/>
+                </a:lnTo>
+                <a:lnTo>
+                  <a:pt x="0" y="0"/>
+                </a:lnTo>
+                <a:close/>
+              </a:path>
+            </a:pathLst>
+          </a:custGeom>
+          <a:blipFill>
+            <a:blip r:embed="rId2"/>
+            <a:stretch>
+              <a:fillRect/>
+            </a:stretch>
+          </a:blipFill>
+        </p:spPr>
+      </p:sp>
+      <p:sp>
+        <p:nvSpPr>
+          <p:cNvPr id="15" name="TextBox 15">
+            <a:extLst>
+              <a:ext uri="{FF2B5EF4-FFF2-40B4-BE49-F238E27FC236}">
+                <a16:creationId xmlns:a16="http://schemas.microsoft.com/office/drawing/2014/main" id="{9EE0DCA4-E9C6-19CF-99A4-2B3788D1B0A2}"/>
+              </a:ext>
+            </a:extLst>
+          </p:cNvPr>
+          <p:cNvSpPr txBox="1"/>
+          <p:nvPr/>
+        </p:nvSpPr>
+        <p:spPr>
+          <a:xfrm>
+            <a:off x="12877800" y="4127770"/>
+            <a:ext cx="325897" cy="350420"/>
+          </a:xfrm>
+          <a:prstGeom prst="rect">
+            <a:avLst/>
+          </a:prstGeom>
+        </p:spPr>
+        <p:txBody>
+          <a:bodyPr lIns="50800" tIns="50800" rIns="50800" bIns="50800" rtlCol="0" anchor="ctr"/>
+          <a:lstStyle/>
+          <a:p>
+            <a:pPr algn="ctr">
+              <a:lnSpc>
+                <a:spcPts val="1387"/>
+              </a:lnSpc>
+            </a:pPr>
+            <a:endParaRPr lang="en-US" sz="990" b="1" i="1" dirty="0">
+              <a:solidFill>
+                <a:srgbClr val="000000"/>
+              </a:solidFill>
+              <a:latin typeface="Open Sans Bold Italics"/>
+              <a:ea typeface="Open Sans Bold Italics"/>
+              <a:cs typeface="Open Sans Bold Italics"/>
+              <a:sym typeface="Open Sans Bold Italics"/>
+            </a:endParaRPr>
+          </a:p>
+        </p:txBody>
+      </p:sp>
+      <p:sp>
+        <p:nvSpPr>
+          <p:cNvPr id="18" name="TextBox 18">
+            <a:extLst>
+              <a:ext uri="{FF2B5EF4-FFF2-40B4-BE49-F238E27FC236}">
+                <a16:creationId xmlns:a16="http://schemas.microsoft.com/office/drawing/2014/main" id="{C95C015A-E605-CF2C-2020-DDE1ABD45020}"/>
+              </a:ext>
+            </a:extLst>
+          </p:cNvPr>
+          <p:cNvSpPr txBox="1"/>
+          <p:nvPr/>
+        </p:nvSpPr>
+        <p:spPr>
+          <a:xfrm>
+            <a:off x="12877800" y="4508837"/>
+            <a:ext cx="325897" cy="350420"/>
+          </a:xfrm>
+          <a:prstGeom prst="rect">
+            <a:avLst/>
+          </a:prstGeom>
+        </p:spPr>
+        <p:txBody>
+          <a:bodyPr lIns="50800" tIns="50800" rIns="50800" bIns="50800" rtlCol="0" anchor="ctr"/>
+          <a:lstStyle/>
+          <a:p>
+            <a:pPr algn="ctr">
+              <a:lnSpc>
+                <a:spcPts val="1387"/>
+              </a:lnSpc>
+            </a:pPr>
+            <a:endParaRPr lang="en-US" sz="990" b="1" i="1" dirty="0">
+              <a:solidFill>
+                <a:srgbClr val="000000"/>
+              </a:solidFill>
+              <a:latin typeface="Open Sans Bold Italics"/>
+              <a:ea typeface="Open Sans Bold Italics"/>
+              <a:cs typeface="Open Sans Bold Italics"/>
+              <a:sym typeface="Open Sans Bold Italics"/>
+            </a:endParaRPr>
+          </a:p>
+        </p:txBody>
+      </p:sp>
+      <p:sp>
+        <p:nvSpPr>
+          <p:cNvPr id="21" name="TextBox 21">
+            <a:extLst>
+              <a:ext uri="{FF2B5EF4-FFF2-40B4-BE49-F238E27FC236}">
+                <a16:creationId xmlns:a16="http://schemas.microsoft.com/office/drawing/2014/main" id="{DE9FC7EA-A1A4-A0ED-9E94-7E64FD511BC5}"/>
+              </a:ext>
+            </a:extLst>
+          </p:cNvPr>
+          <p:cNvSpPr txBox="1"/>
+          <p:nvPr/>
+        </p:nvSpPr>
+        <p:spPr>
+          <a:xfrm>
+            <a:off x="12877800" y="4891702"/>
+            <a:ext cx="325897" cy="350420"/>
+          </a:xfrm>
+          <a:prstGeom prst="rect">
+            <a:avLst/>
+          </a:prstGeom>
+        </p:spPr>
+        <p:txBody>
+          <a:bodyPr lIns="50800" tIns="50800" rIns="50800" bIns="50800" rtlCol="0" anchor="ctr"/>
+          <a:lstStyle/>
+          <a:p>
+            <a:pPr algn="ctr">
+              <a:lnSpc>
+                <a:spcPts val="1387"/>
+              </a:lnSpc>
+            </a:pPr>
+            <a:endParaRPr lang="en-US" sz="990" b="1" i="1" dirty="0">
+              <a:solidFill>
+                <a:srgbClr val="000000"/>
+              </a:solidFill>
+              <a:latin typeface="Open Sans Bold Italics"/>
+              <a:ea typeface="Open Sans Bold Italics"/>
+              <a:cs typeface="Open Sans Bold Italics"/>
+              <a:sym typeface="Open Sans Bold Italics"/>
+            </a:endParaRPr>
+          </a:p>
+        </p:txBody>
+      </p:sp>
+      <p:sp>
+        <p:nvSpPr>
+          <p:cNvPr id="24" name="TextBox 24">
+            <a:extLst>
+              <a:ext uri="{FF2B5EF4-FFF2-40B4-BE49-F238E27FC236}">
+                <a16:creationId xmlns:a16="http://schemas.microsoft.com/office/drawing/2014/main" id="{3AB776F1-B6AA-1FE8-5566-BEEBDEBE783C}"/>
+              </a:ext>
+            </a:extLst>
+          </p:cNvPr>
+          <p:cNvSpPr txBox="1"/>
+          <p:nvPr/>
+        </p:nvSpPr>
+        <p:spPr>
+          <a:xfrm>
+            <a:off x="12877800" y="5274567"/>
+            <a:ext cx="325897" cy="350420"/>
+          </a:xfrm>
+          <a:prstGeom prst="rect">
+            <a:avLst/>
+          </a:prstGeom>
+        </p:spPr>
+        <p:txBody>
+          <a:bodyPr lIns="50800" tIns="50800" rIns="50800" bIns="50800" rtlCol="0" anchor="ctr"/>
+          <a:lstStyle/>
+          <a:p>
+            <a:pPr algn="ctr">
+              <a:lnSpc>
+                <a:spcPts val="1387"/>
+              </a:lnSpc>
+            </a:pPr>
+            <a:endParaRPr lang="en-US" sz="990" b="1" i="1" dirty="0">
+              <a:solidFill>
+                <a:srgbClr val="000000"/>
+              </a:solidFill>
+              <a:latin typeface="Open Sans Bold Italics"/>
+              <a:ea typeface="Open Sans Bold Italics"/>
+              <a:cs typeface="Open Sans Bold Italics"/>
+              <a:sym typeface="Open Sans Bold Italics"/>
+            </a:endParaRPr>
+          </a:p>
+        </p:txBody>
+      </p:sp>
+      <p:grpSp>
+        <p:nvGrpSpPr>
+          <p:cNvPr id="58" name="Group 58">
+            <a:extLst>
+              <a:ext uri="{FF2B5EF4-FFF2-40B4-BE49-F238E27FC236}">
+                <a16:creationId xmlns:a16="http://schemas.microsoft.com/office/drawing/2014/main" id="{A3974981-F480-DC39-3103-7FAE80C01DDA}"/>
+              </a:ext>
+            </a:extLst>
+          </p:cNvPr>
+          <p:cNvGrpSpPr/>
+          <p:nvPr/>
+        </p:nvGrpSpPr>
+        <p:grpSpPr>
+          <a:xfrm>
+            <a:off x="6605400" y="2472975"/>
+            <a:ext cx="5154571" cy="980717"/>
+            <a:chOff x="0" y="0"/>
+            <a:chExt cx="1357582" cy="258296"/>
+          </a:xfrm>
+        </p:grpSpPr>
+        <p:sp>
+          <p:nvSpPr>
+            <p:cNvPr id="59" name="Freeform 59">
+              <a:extLst>
+                <a:ext uri="{FF2B5EF4-FFF2-40B4-BE49-F238E27FC236}">
+                  <a16:creationId xmlns:a16="http://schemas.microsoft.com/office/drawing/2014/main" id="{D908CD74-4417-C1D7-9F15-F53847448DD5}"/>
+                </a:ext>
+              </a:extLst>
+            </p:cNvPr>
+            <p:cNvSpPr/>
+            <p:nvPr/>
+          </p:nvSpPr>
+          <p:spPr>
+            <a:xfrm>
+              <a:off x="0" y="0"/>
+              <a:ext cx="1357582" cy="258296"/>
+            </a:xfrm>
+            <a:custGeom>
+              <a:avLst/>
+              <a:gdLst/>
+              <a:ahLst/>
+              <a:cxnLst/>
+              <a:rect l="l" t="t" r="r" b="b"/>
+              <a:pathLst>
+                <a:path w="1357582" h="258296">
+                  <a:moveTo>
+                    <a:pt x="0" y="0"/>
+                  </a:moveTo>
+                  <a:lnTo>
+                    <a:pt x="1357582" y="0"/>
+                  </a:lnTo>
+                  <a:lnTo>
+                    <a:pt x="1357582" y="258296"/>
+                  </a:lnTo>
+                  <a:lnTo>
+                    <a:pt x="0" y="258296"/>
+                  </a:lnTo>
+                  <a:close/>
+                </a:path>
+              </a:pathLst>
+            </a:custGeom>
+            <a:solidFill>
+              <a:srgbClr val="FFD300"/>
+            </a:solidFill>
+          </p:spPr>
+        </p:sp>
+        <p:sp>
+          <p:nvSpPr>
+            <p:cNvPr id="60" name="TextBox 60">
+              <a:extLst>
+                <a:ext uri="{FF2B5EF4-FFF2-40B4-BE49-F238E27FC236}">
+                  <a16:creationId xmlns:a16="http://schemas.microsoft.com/office/drawing/2014/main" id="{7947AEB2-B98C-4228-4BE7-0B1CE5D7018E}"/>
+                </a:ext>
+              </a:extLst>
+            </p:cNvPr>
+            <p:cNvSpPr txBox="1"/>
+            <p:nvPr/>
+          </p:nvSpPr>
+          <p:spPr>
+            <a:xfrm>
+              <a:off x="0" y="-38100"/>
+              <a:ext cx="1357582" cy="296396"/>
+            </a:xfrm>
+            <a:prstGeom prst="rect">
+              <a:avLst/>
+            </a:prstGeom>
+          </p:spPr>
+          <p:txBody>
+            <a:bodyPr lIns="50800" tIns="50800" rIns="50800" bIns="50800" rtlCol="0" anchor="ctr"/>
+            <a:lstStyle/>
+            <a:p>
+              <a:pPr algn="ctr">
+                <a:lnSpc>
+                  <a:spcPts val="3067"/>
+                </a:lnSpc>
+              </a:pPr>
+              <a:endParaRPr/>
+            </a:p>
+          </p:txBody>
+        </p:sp>
+      </p:grpSp>
+      <p:sp>
+        <p:nvSpPr>
+          <p:cNvPr id="63" name="TextBox 63">
+            <a:extLst>
+              <a:ext uri="{FF2B5EF4-FFF2-40B4-BE49-F238E27FC236}">
+                <a16:creationId xmlns:a16="http://schemas.microsoft.com/office/drawing/2014/main" id="{FB7A59EE-7BF9-6A7D-5196-D49CF623E00B}"/>
+              </a:ext>
+            </a:extLst>
+          </p:cNvPr>
+          <p:cNvSpPr txBox="1"/>
+          <p:nvPr/>
+        </p:nvSpPr>
+        <p:spPr>
+          <a:xfrm>
+            <a:off x="7020766" y="2419315"/>
+            <a:ext cx="4485434" cy="918778"/>
+          </a:xfrm>
+          <a:prstGeom prst="rect">
+            <a:avLst/>
+          </a:prstGeom>
+        </p:spPr>
+        <p:txBody>
+          <a:bodyPr wrap="square" lIns="0" tIns="0" rIns="0" bIns="0" rtlCol="0" anchor="t">
+            <a:spAutoFit/>
+          </a:bodyPr>
+          <a:lstStyle/>
+          <a:p>
+            <a:pPr algn="ctr">
+              <a:lnSpc>
+                <a:spcPts val="7934"/>
+              </a:lnSpc>
+            </a:pPr>
+            <a:r>
+              <a:rPr lang="en-US" sz="4800" b="1" i="1" dirty="0">
+                <a:latin typeface="Open Sans" panose="020B0606030504020204" pitchFamily="34" charset="0"/>
+                <a:ea typeface="Open Sans" panose="020B0606030504020204" pitchFamily="34" charset="0"/>
+                <a:cs typeface="Open Sans" panose="020B0606030504020204" pitchFamily="34" charset="0"/>
+                <a:sym typeface="Open Sans Bold Italics"/>
+              </a:rPr>
+              <a:t>COMBO UNO</a:t>
+            </a:r>
+          </a:p>
+        </p:txBody>
+      </p:sp>
+      <p:sp>
+        <p:nvSpPr>
+          <p:cNvPr id="4" name="TextBox 3">
+            <a:extLst>
+              <a:ext uri="{FF2B5EF4-FFF2-40B4-BE49-F238E27FC236}">
+                <a16:creationId xmlns:a16="http://schemas.microsoft.com/office/drawing/2014/main" id="{FFB334B0-8ADF-8EAE-C037-048D0D3FB2A5}"/>
+              </a:ext>
+            </a:extLst>
+          </p:cNvPr>
+          <p:cNvSpPr txBox="1"/>
+          <p:nvPr/>
+        </p:nvSpPr>
+        <p:spPr>
+          <a:xfrm>
+            <a:off x="6063083" y="4314663"/>
+            <a:ext cx="6400800" cy="400110"/>
+          </a:xfrm>
+          <a:prstGeom prst="rect">
+            <a:avLst/>
+          </a:prstGeom>
+          <a:noFill/>
+        </p:spPr>
+        <p:txBody>
+          <a:bodyPr wrap="square" rtlCol="0">
+            <a:spAutoFit/>
+          </a:bodyPr>
+          <a:lstStyle/>
+          <a:p>
+            <a:pPr algn="ctr"/>
+            <a:r>
+              <a:rPr lang="pt-BR" sz="2000" dirty="0">
+                <a:latin typeface="Open Sans Bold" pitchFamily="2" charset="0"/>
+                <a:ea typeface="Open Sans Bold" pitchFamily="2" charset="0"/>
+                <a:cs typeface="Open Sans Bold" pitchFamily="2" charset="0"/>
+              </a:rPr>
+              <a:t>[EXTRAS]</a:t>
+            </a:r>
+          </a:p>
+        </p:txBody>
+      </p:sp>
+    </p:spTree>
+    <p:extLst>
+      <p:ext uri="{BB962C8B-B14F-4D97-AF65-F5344CB8AC3E}">
+        <p14:creationId xmlns:p14="http://schemas.microsoft.com/office/powerpoint/2010/main" val="3226342844"/>
+      </p:ext>
+    </p:extLst>
+  </p:cSld>
+  <p:clrMapOvr>
+    <a:masterClrMapping/>
+  </p:clrMapOvr>
+</p:sld>
+</file>
+
+<file path=ppt/slides/slide24.xml><?xml version="1.0" encoding="utf-8"?>
+<p:sld xmlns:a="http://schemas.openxmlformats.org/drawingml/2006/main" xmlns:r="http://schemas.openxmlformats.org/officeDocument/2006/relationships" xmlns:p="http://schemas.openxmlformats.org/presentationml/2006/main">
+  <p:cSld>
+    <p:spTree>
+      <p:nvGrpSpPr>
         <p:cNvPr id="1" name=""/>
         <p:cNvGrpSpPr/>
         <p:nvPr/>
@@ -7180,7 +7618,7 @@
 </p:sld>
 </file>
 
-<file path=ppt/slides/slide24.xml><?xml version="1.0" encoding="utf-8"?>
+<file path=ppt/slides/slide25.xml><?xml version="1.0" encoding="utf-8"?>
 <p:sld xmlns:a="http://schemas.openxmlformats.org/drawingml/2006/main" xmlns:r="http://schemas.openxmlformats.org/officeDocument/2006/relationships" xmlns:p="http://schemas.openxmlformats.org/presentationml/2006/main">
   <p:cSld>
     <p:spTree>

</xml_diff>